<commit_message>
added another verison of app.py
</commit_message>
<xml_diff>
--- a/presentation/PODSV_Presentation_Group11.pptx
+++ b/presentation/PODSV_Presentation_Group11.pptx
@@ -514,7 +514,7 @@
           <a:p>
             <a:r>
               <a:rPr lang="en-US" dirty="0"/>
-              <a:t/>
+              <a:t>Welcome — we're Group 11: Lara, Jonathan and Veprim. Our project tackles a practical question for grocery delivery: how do you decide what to stock and where to place it, using only past purchase data? We built an interactive dashboard on 3.2 million real Instacart orders. Over the next few minutes I'll cover the challenge, the data, who the tool is for, and the six findings that came out of it.</a:t>
             </a:r>
             <a:endParaRPr lang="en-US" dirty="0"/>
           </a:p>
@@ -602,7 +602,7 @@
           <a:p>
             <a:r>
               <a:rPr lang="en-US" dirty="0"/>
-              <a:t/>
+              <a:t>Hidden gems. Here we deliberately excluded the five biggest departments and asked: what still keeps customers coming back? Breads, hams and wraps reach 78 to 83% reorder rates despite low overall volume — a small but very loyal customer base that is completely invisible in a standard top-sellers report. Recommendation: protect these niche products from delisting; they punch well above their volume in retention terms.</a:t>
             </a:r>
             <a:endParaRPr lang="en-US" dirty="0"/>
           </a:p>
@@ -690,7 +690,7 @@
           <a:p>
             <a:r>
               <a:rPr lang="en-US" dirty="0"/>
-              <a:t/>
+              <a:t>Finally, timing. Orders concentrate heavily on Sunday and Monday, roughly between 9am and 4pm — people plan their weekly groceries at the start of the week. Activity falls away sharply before 7am and after 7pm on every day. Recommendation: staff up for that weekly peak, and push promotions on Saturday evening to catch the early planners before the Sunday surge.</a:t>
             </a:r>
             <a:endParaRPr lang="en-US" dirty="0"/>
           </a:p>
@@ -778,7 +778,7 @@
           <a:p>
             <a:r>
               <a:rPr lang="en-US" dirty="0"/>
-              <a:t/>
+              <a:t>Pulling it together — four decisions the data supports. One, build on fresh: produce and a credible organic range are the non-negotiable core; that's mainly for Sandra. Two, bundle the clusters: group co-purchased products and cross-sell across the strongest links — that's for Marco. Three, subscribe the staples: milk, water and other high-reorder items are perfect for subscriptions and auto-reorders. Four, protect the gems: keep loyal niche products on the shelf even when their volume looks small. Each one ties straight back to a finding you've just seen.</a:t>
             </a:r>
             <a:endParaRPr lang="en-US" dirty="0"/>
           </a:p>
@@ -866,7 +866,7 @@
           <a:p>
             <a:r>
               <a:rPr lang="en-US" dirty="0"/>
-              <a:t/>
+              <a:t>To wrap up — the dashboard turns three million anonymised orders into decisions Sandra and Marco can actually act on: faster, more intuitively, and without writing a line of code. The repository and the run command are on screen. Thank you — we're happy to take any questions.</a:t>
             </a:r>
             <a:endParaRPr lang="en-US" dirty="0"/>
           </a:p>
@@ -954,7 +954,7 @@
           <a:p>
             <a:r>
               <a:rPr lang="en-US" dirty="0"/>
-              <a:t/>
+              <a:t>Quick-commerce platforms like Flink or Gorillas manage assortments of thousands of products, constantly balancing customer demand, storage capacity and delivery efficiency. The assortment planners and buyers who make these calls do it every week — and often from slow, error-prone Excel reports. Our goal was to give them a faster, more visual, data-driven foundation. These five questions framed the entire project: what's bought most, what's bought together, what earns loyalty, when people order, and what all of that means for strategy.</a:t>
             </a:r>
             <a:endParaRPr lang="en-US" dirty="0"/>
           </a:p>
@@ -1042,7 +1042,7 @@
           <a:p>
             <a:r>
               <a:rPr lang="en-US" dirty="0"/>
-              <a:t/>
+              <a:t>Everything runs on the Instacart Online Grocery dataset from 2017 — a public, fully anonymised set of US grocery-delivery orders. It's six linked tables: orders, order-products, products, aisles and departments. Around 3.4 million orders in total, of which the 3.2 million 'prior' orders are the basis for every chart you'll see. One caveat to keep in mind: there are no absolute dates — only day-of-week and hour — and it reflects US behaviour in 2017, so we read it as patterns, not exact forecasts.</a:t>
             </a:r>
             <a:endParaRPr lang="en-US" dirty="0"/>
           </a:p>
@@ -1130,7 +1130,7 @@
           <a:p>
             <a:r>
               <a:rPr lang="en-US" dirty="0"/>
-              <a:t/>
+              <a:t>The dashboard is built for two people. Sandra is an assortment planner — 34, business background, five years in grocery retail, comfortable with Excel but not code. She needs a fast visual overview without manual prep, and she's frustrated that co-purchase relationships are invisible in her current tools. Marco is a buyer — 28, two years in e-commerce grocery. He needs hard evidence for listing and delisting decisions and for supplier talks, and today too much rides on intuition while loyal niche products never surface in standard reports. Every view in the dashboard maps back to one of their jobs.</a:t>
             </a:r>
             <a:endParaRPr lang="en-US" dirty="0"/>
           </a:p>
@@ -1218,7 +1218,7 @@
           <a:p>
             <a:r>
               <a:rPr lang="en-US" dirty="0"/>
-              <a:t/>
+              <a:t>The deliverable is an interactive Streamlit dashboard — built for exploration, not static reporting. It has three sections that mirror how planners and buyers actually think. KPI Overview is the landing page: six headline metrics for instant orientation. Product Development answers what sells and what sells together — top sellers, department sales, and the products-bought-together network graph. Customer Retention covers who comes back and when — reorder rate, hidden gems, and the shopping-time heatmap. The whole thing runs locally with a single command.</a:t>
             </a:r>
             <a:endParaRPr lang="en-US" dirty="0"/>
           </a:p>
@@ -1306,7 +1306,7 @@
           <a:p>
             <a:r>
               <a:rPr lang="en-US" dirty="0"/>
-              <a:t/>
+              <a:t>This is the top-sellers view. Bananas are the single most-purchased product at 0.47 million, followed by Bag of Organic Bananas and Organic Strawberries. The striking thing is that the entire top 15 is fresh fruit and vegetables — and more than half carry an 'Organic' label. The recommendation for Sandra: fresh produce and a credible organic range aren't optional, they're the non-negotiable core of the assortment.</a:t>
             </a:r>
             <a:endParaRPr lang="en-US" dirty="0"/>
           </a:p>
@@ -1394,7 +1394,7 @@
           <a:p>
             <a:r>
               <a:rPr lang="en-US" dirty="0"/>
-              <a:t/>
+              <a:t>Stepping up from individual products to departments. Produce drives roughly 9.5 million purchases and Dairy &amp; Eggs about 5.4 million — together nearly half of all volume. The next tier — snacks, beverages, frozen and pantry — is all convenience food. Bulk, alcohol and pets barely register. Recommendation: anchor the assortment on produce and dairy, and treat the convenience categories as the growth layer on top.</a:t>
             </a:r>
             <a:endParaRPr lang="en-US" dirty="0"/>
           </a:p>
@@ -1482,7 +1482,7 @@
           <a:p>
             <a:r>
               <a:rPr lang="en-US" dirty="0"/>
-              <a:t/>
+              <a:t>For the co-purchase analysis we grouped every product into its aisle — 134 of them — and asked which aisles get bought together far more often than chance. Four baskets emerge. The biggest is a cooking basket: fresh produce, dairy, meat and the pantry staples — pasta, sauce, oils, spices — that go into home-cooked meals. The second is a convenience and household run: snacks, drinks and frozen meals plus cleaning and personal-care items. Third, and very distinct, is the drinks run — beer, wine and spirits cluster tightly and largely on their own. Fourth is a small health-and-bulk basket. Two honest notes worth saying out loud: pasta does not form its own cluster — it sits inside the cooking basket with sauce and cheese, which makes sense — and snacks group with the convenience run, not with pasta. So the earlier 'pasta cluster / snack cluster' framing isn't what the data shows; this aisle-level view is the more defensible picture. Recommendation: merchandise around these shopping missions — cross-sell within the cooking basket, bundle the convenience run, and treat alcohol as its own zone.</a:t>
             </a:r>
             <a:endParaRPr lang="en-US" dirty="0"/>
           </a:p>
@@ -1570,7 +1570,7 @@
           <a:p>
             <a:r>
               <a:rPr lang="en-US" dirty="0"/>
-              <a:t/>
+              <a:t>Now to retention. The overall reorder rate across the dataset is 58.9% — that alone tells us this is a highly habitual customer base. When we look at products with at least 500 purchases, the very highest reorder rates, 84 to 86%, are almost entirely milk and water — pure everyday staples. Recommendation: these staples are ideal candidates for subscriptions and automatic reorder reminders.</a:t>
             </a:r>
             <a:endParaRPr lang="en-US" dirty="0"/>
           </a:p>
@@ -2080,7 +2080,7 @@
                 <a:ea typeface="Calibri" pitchFamily="34" charset="-122"/>
                 <a:cs typeface="Calibri" pitchFamily="34" charset="-120"/>
               </a:rPr>
-              <a:t>An interactive dashboard that turns 3.2 million Instacart orders into assortment, cross-sell and retention decisions for grocery delivery.</a:t>
+              <a:t>Turning 3.2 million Instacart orders into assortment, cross-sell and retention decisions for grocery delivery.</a:t>
             </a:r>
             <a:endParaRPr lang="en-US" sz="1700" dirty="0"/>
           </a:p>
@@ -3015,30 +3015,16 @@
         </p:nvSpPr>
         <p:spPr>
           <a:xfrm>
-            <a:off x="7986461" y="1874520"/>
-            <a:ext cx="3427994" cy="2971800"/>
-          </a:xfrm>
-          <a:prstGeom prst="roundRect">
-            <a:avLst>
-              <a:gd name="adj" fmla="val 2462"/>
-            </a:avLst>
+            <a:off x="8077901" y="2400300"/>
+            <a:ext cx="64008" cy="3291840"/>
+          </a:xfrm>
+          <a:prstGeom prst="rect">
+            <a:avLst/>
           </a:prstGeom>
           <a:solidFill>
-            <a:srgbClr val="EEF2EC"/>
+            <a:srgbClr val="E07A3F"/>
           </a:solidFill>
-          <a:ln w="12700">
-            <a:solidFill>
-              <a:srgbClr val="D8E0D4"/>
-            </a:solidFill>
-            <a:prstDash val="solid"/>
-          </a:ln>
-          <a:effectLst>
-            <a:outerShdw sx="100000" sy="100000" kx="0" ky="0" algn="bl" rotWithShape="0" blurRad="114300" dist="38100" dir="8100000">
-              <a:srgbClr val="1C2E22">
-                <a:alpha val="16000"/>
-              </a:srgbClr>
-            </a:outerShdw>
-          </a:effectLst>
+          <a:ln/>
         </p:spPr>
       </p:sp>
       <p:sp>
@@ -3049,8 +3035,8 @@
         </p:nvSpPr>
         <p:spPr>
           <a:xfrm>
-            <a:off x="8279069" y="2121408"/>
-            <a:ext cx="2842778" cy="274320"/>
+            <a:off x="8370509" y="2171700"/>
+            <a:ext cx="3043946" cy="3749040"/>
           </a:xfrm>
           <a:prstGeom prst="rect">
             <a:avLst/>
@@ -3063,10 +3049,16 @@
           <a:lstStyle/>
           <a:p>
             <a:pPr indent="0" marL="0">
-              <a:buNone/>
-            </a:pPr>
-            <a:r>
-              <a:rPr lang="en-US" sz="1100" b="1" spc="200" kern="0" dirty="0">
+              <a:lnSpc>
+                <a:spcPts val="2600"/>
+              </a:lnSpc>
+              <a:spcAft>
+                <a:spcPts val="1000"/>
+              </a:spcAft>
+              <a:buNone/>
+            </a:pPr>
+            <a:r>
+              <a:rPr lang="en-US" sz="1150" b="1" spc="200" kern="0" dirty="0">
                 <a:solidFill>
                   <a:srgbClr val="2F6E4F"/>
                 </a:solidFill>
@@ -3074,44 +3066,20 @@
                 <a:ea typeface="Calibri" pitchFamily="34" charset="-122"/>
                 <a:cs typeface="Calibri" pitchFamily="34" charset="-120"/>
               </a:rPr>
-              <a:t>KEY FINDING</a:t>
-            </a:r>
-            <a:endParaRPr lang="en-US" sz="1100" dirty="0"/>
-          </a:p>
-        </p:txBody>
-      </p:sp>
-      <p:sp>
-        <p:nvSpPr>
-          <p:cNvPr id="7" name="Text 4"/>
-          <p:cNvSpPr/>
-          <p:nvPr/>
-        </p:nvSpPr>
-        <p:spPr>
-          <a:xfrm>
-            <a:off x="8279069" y="2432304"/>
-            <a:ext cx="2842778" cy="2286000"/>
-          </a:xfrm>
-          <a:prstGeom prst="rect">
-            <a:avLst/>
-          </a:prstGeom>
-          <a:noFill/>
-          <a:ln/>
-        </p:spPr>
-        <p:txBody>
-          <a:bodyPr wrap="square" lIns="0" tIns="0" rIns="0" bIns="0" rtlCol="0" anchor="t"/>
-          <a:lstStyle/>
-          <a:p>
+              <a:t>WHAT WE FOUND
+</a:t>
+            </a:r>
             <a:pPr indent="0" marL="0">
               <a:lnSpc>
-                <a:spcPts val="1800"/>
+                <a:spcPts val="2600"/>
               </a:lnSpc>
               <a:spcAft>
-                <a:spcPts val="800"/>
+                <a:spcPts val="1000"/>
               </a:spcAft>
               <a:buNone/>
             </a:pPr>
             <a:r>
-              <a:rPr lang="en-US" sz="1600" b="1" dirty="0">
+              <a:rPr lang="en-US" sz="2100" b="1" dirty="0">
                 <a:solidFill>
                   <a:srgbClr val="1C2E22"/>
                 </a:solidFill>
@@ -3119,145 +3087,45 @@
                 <a:ea typeface="Georgia" pitchFamily="34" charset="-122"/>
                 <a:cs typeface="Georgia" pitchFamily="34" charset="-120"/>
               </a:rPr>
-              <a:t>Small categories, surprisingly loyal customers.</a:t>
-            </a:r>
-            <a:endParaRPr lang="en-US" sz="1600" dirty="0"/>
-          </a:p>
-          <a:p>
-            <a:pPr indent="0" marL="0">
-              <a:lnSpc>
-                <a:spcPts val="1800"/>
-              </a:lnSpc>
-              <a:buNone/>
-            </a:pPr>
-            <a:r>
-              <a:rPr lang="en-US" sz="1250" dirty="0">
-                <a:solidFill>
-                  <a:srgbClr val="1C2E22"/>
+              <a:t>Niche breads and deli items keep 78 to 83% of their buyers.</a:t>
+            </a:r>
+            <a:endParaRPr lang="en-US" sz="1150" dirty="0"/>
+          </a:p>
+        </p:txBody>
+      </p:sp>
+      <p:sp>
+        <p:nvSpPr>
+          <p:cNvPr id="8" name="Text 4"/>
+          <p:cNvSpPr/>
+          <p:nvPr/>
+        </p:nvSpPr>
+        <p:spPr>
+          <a:xfrm>
+            <a:off x="777240" y="6455664"/>
+            <a:ext cx="7315200" cy="274320"/>
+          </a:xfrm>
+          <a:prstGeom prst="rect">
+            <a:avLst/>
+          </a:prstGeom>
+          <a:noFill/>
+          <a:ln/>
+        </p:spPr>
+        <p:txBody>
+          <a:bodyPr wrap="square" lIns="0" tIns="0" rIns="0" bIns="0" rtlCol="0" anchor="ctr"/>
+          <a:lstStyle/>
+          <a:p>
+            <a:pPr algn="l" indent="0" marL="0">
+              <a:buNone/>
+            </a:pPr>
+            <a:r>
+              <a:rPr lang="en-US" sz="900" dirty="0">
+                <a:solidFill>
+                  <a:srgbClr val="6B7A6E"/>
                 </a:solidFill>
                 <a:latin typeface="Calibri" pitchFamily="34" charset="0"/>
                 <a:ea typeface="Calibri" pitchFamily="34" charset="-122"/>
                 <a:cs typeface="Calibri" pitchFamily="34" charset="-120"/>
               </a:rPr>
-              <a:t>Outside the five biggest departments, breads, hams and wraps still reach 78–83% reorder rates despite low volume — a loyal base that is invisible in standard reports.</a:t>
-            </a:r>
-            <a:endParaRPr lang="en-US" sz="1600" dirty="0"/>
-          </a:p>
-        </p:txBody>
-      </p:sp>
-      <p:sp>
-        <p:nvSpPr>
-          <p:cNvPr id="8" name="Shape 5"/>
-          <p:cNvSpPr/>
-          <p:nvPr/>
-        </p:nvSpPr>
-        <p:spPr>
-          <a:xfrm>
-            <a:off x="7986461" y="5074920"/>
-            <a:ext cx="64008" cy="1097280"/>
-          </a:xfrm>
-          <a:prstGeom prst="rect">
-            <a:avLst/>
-          </a:prstGeom>
-          <a:solidFill>
-            <a:srgbClr val="E07A3F"/>
-          </a:solidFill>
-          <a:ln/>
-        </p:spPr>
-      </p:sp>
-      <p:sp>
-        <p:nvSpPr>
-          <p:cNvPr id="9" name="Text 6"/>
-          <p:cNvSpPr/>
-          <p:nvPr/>
-        </p:nvSpPr>
-        <p:spPr>
-          <a:xfrm>
-            <a:off x="8233349" y="5074920"/>
-            <a:ext cx="3181106" cy="1097280"/>
-          </a:xfrm>
-          <a:prstGeom prst="rect">
-            <a:avLst/>
-          </a:prstGeom>
-          <a:noFill/>
-          <a:ln/>
-        </p:spPr>
-        <p:txBody>
-          <a:bodyPr wrap="square" lIns="0" tIns="0" rIns="0" bIns="0" rtlCol="0" anchor="t"/>
-          <a:lstStyle/>
-          <a:p>
-            <a:pPr indent="0" marL="0">
-              <a:lnSpc>
-                <a:spcPts val="1600"/>
-              </a:lnSpc>
-              <a:buNone/>
-            </a:pPr>
-            <a:r>
-              <a:rPr lang="en-US" sz="1050" b="1" spc="150" kern="0" dirty="0">
-                <a:solidFill>
-                  <a:srgbClr val="E07A3F"/>
-                </a:solidFill>
-                <a:latin typeface="Calibri" pitchFamily="34" charset="0"/>
-                <a:ea typeface="Calibri" pitchFamily="34" charset="-122"/>
-                <a:cs typeface="Calibri" pitchFamily="34" charset="-120"/>
-              </a:rPr>
-              <a:t>RECOMMENDATION
-</a:t>
-            </a:r>
-            <a:pPr indent="0" marL="0">
-              <a:lnSpc>
-                <a:spcPts val="1600"/>
-              </a:lnSpc>
-              <a:buNone/>
-            </a:pPr>
-            <a:r>
-              <a:rPr lang="en-US" sz="1250" dirty="0">
-                <a:solidFill>
-                  <a:srgbClr val="1C2E22"/>
-                </a:solidFill>
-                <a:latin typeface="Calibri" pitchFamily="34" charset="0"/>
-                <a:ea typeface="Calibri" pitchFamily="34" charset="-122"/>
-                <a:cs typeface="Calibri" pitchFamily="34" charset="-120"/>
-              </a:rPr>
-              <a:t>Protect these niche products from delisting; they punch above their volume in retention.</a:t>
-            </a:r>
-            <a:endParaRPr lang="en-US" sz="1050" dirty="0"/>
-          </a:p>
-        </p:txBody>
-      </p:sp>
-      <p:sp>
-        <p:nvSpPr>
-          <p:cNvPr id="10" name="Text 7"/>
-          <p:cNvSpPr/>
-          <p:nvPr/>
-        </p:nvSpPr>
-        <p:spPr>
-          <a:xfrm>
-            <a:off x="777240" y="6455664"/>
-            <a:ext cx="7315200" cy="274320"/>
-          </a:xfrm>
-          <a:prstGeom prst="rect">
-            <a:avLst/>
-          </a:prstGeom>
-          <a:noFill/>
-          <a:ln/>
-        </p:spPr>
-        <p:txBody>
-          <a:bodyPr wrap="square" lIns="0" tIns="0" rIns="0" bIns="0" rtlCol="0" anchor="ctr"/>
-          <a:lstStyle/>
-          <a:p>
-            <a:pPr algn="l" indent="0" marL="0">
-              <a:buNone/>
-            </a:pPr>
-            <a:r>
-              <a:rPr lang="en-US" sz="900" dirty="0">
-                <a:solidFill>
-                  <a:srgbClr val="6B7A6E"/>
-                </a:solidFill>
-                <a:latin typeface="Calibri" pitchFamily="34" charset="0"/>
-                <a:ea typeface="Calibri" pitchFamily="34" charset="-122"/>
-                <a:cs typeface="Calibri" pitchFamily="34" charset="-120"/>
-              </a:rPr>
               <a:t>Grocery Product Placement Analysis  ·  Group 11</a:t>
             </a:r>
             <a:endParaRPr lang="en-US" sz="900" dirty="0"/>
@@ -3266,7 +3134,7 @@
       </p:sp>
       <p:sp>
         <p:nvSpPr>
-          <p:cNvPr id="11" name="Text 8"/>
+          <p:cNvPr id="9" name="Text 5"/>
           <p:cNvSpPr/>
           <p:nvPr/>
         </p:nvSpPr>
@@ -3429,7 +3297,7 @@
         </p:blipFill>
         <p:spPr>
           <a:xfrm>
-            <a:off x="1340968" y="1783080"/>
+            <a:off x="1340968" y="1828800"/>
             <a:ext cx="9509760" cy="3423240"/>
           </a:xfrm>
           <a:prstGeom prst="rect">
@@ -3445,62 +3313,28 @@
         </p:nvSpPr>
         <p:spPr>
           <a:xfrm>
-            <a:off x="777240" y="5285232"/>
-            <a:ext cx="10634472" cy="960120"/>
-          </a:xfrm>
-          <a:prstGeom prst="roundRect">
-            <a:avLst>
-              <a:gd name="adj" fmla="val 7619"/>
-            </a:avLst>
+            <a:off x="777240" y="5532120"/>
+            <a:ext cx="64008" cy="566928"/>
+          </a:xfrm>
+          <a:prstGeom prst="rect">
+            <a:avLst/>
           </a:prstGeom>
           <a:solidFill>
-            <a:srgbClr val="EEF2EC"/>
+            <a:srgbClr val="E07A3F"/>
           </a:solidFill>
-          <a:ln w="12700">
-            <a:solidFill>
-              <a:srgbClr val="D8E0D4"/>
-            </a:solidFill>
-            <a:prstDash val="solid"/>
-          </a:ln>
-          <a:effectLst>
-            <a:outerShdw sx="100000" sy="100000" kx="0" ky="0" algn="bl" rotWithShape="0" blurRad="114300" dist="38100" dir="8100000">
-              <a:srgbClr val="1C2E22">
-                <a:alpha val="16000"/>
-              </a:srgbClr>
-            </a:outerShdw>
-          </a:effectLst>
-        </p:spPr>
-      </p:sp>
-      <p:sp>
-        <p:nvSpPr>
-          <p:cNvPr id="6" name="Shape 3"/>
-          <p:cNvSpPr/>
-          <p:nvPr/>
-        </p:nvSpPr>
-        <p:spPr>
-          <a:xfrm>
-            <a:off x="777240" y="5285232"/>
-            <a:ext cx="64008" cy="960120"/>
-          </a:xfrm>
-          <a:prstGeom prst="rect">
-            <a:avLst/>
-          </a:prstGeom>
-          <a:solidFill>
-            <a:srgbClr val="2F6E4F"/>
-          </a:solidFill>
-          <a:ln/>
-        </p:spPr>
-      </p:sp>
-      <p:sp>
-        <p:nvSpPr>
-          <p:cNvPr id="7" name="Text 4"/>
-          <p:cNvSpPr/>
-          <p:nvPr/>
-        </p:nvSpPr>
-        <p:spPr>
-          <a:xfrm>
-            <a:off x="1069848" y="5358384"/>
-            <a:ext cx="10058400" cy="813816"/>
+          <a:ln/>
+        </p:spPr>
+      </p:sp>
+      <p:sp>
+        <p:nvSpPr>
+          <p:cNvPr id="6" name="Text 3"/>
+          <p:cNvSpPr/>
+          <p:nvPr/>
+        </p:nvSpPr>
+        <p:spPr>
+          <a:xfrm>
+            <a:off x="1069848" y="5504688"/>
+            <a:ext cx="10424160" cy="640080"/>
           </a:xfrm>
           <a:prstGeom prst="rect">
             <a:avLst/>
@@ -3514,12 +3348,12 @@
           <a:p>
             <a:pPr indent="0" marL="0">
               <a:lnSpc>
-                <a:spcPts val="1600"/>
+                <a:spcPts val="1900"/>
               </a:lnSpc>
               <a:buNone/>
             </a:pPr>
             <a:r>
-              <a:rPr lang="en-US" sz="1050" b="1" spc="150" kern="0" dirty="0">
+              <a:rPr lang="en-US" sz="1150" b="1" spc="200" kern="0" dirty="0">
                 <a:solidFill>
                   <a:srgbClr val="2F6E4F"/>
                 </a:solidFill>
@@ -3527,106 +3361,71 @@
                 <a:ea typeface="Calibri" pitchFamily="34" charset="-122"/>
                 <a:cs typeface="Calibri" pitchFamily="34" charset="-120"/>
               </a:rPr>
-              <a:t>KEY FINDING   </a:t>
+              <a:t>WHAT WE FOUND   </a:t>
             </a:r>
             <a:pPr indent="0" marL="0">
               <a:lnSpc>
-                <a:spcPts val="1600"/>
+                <a:spcPts val="1900"/>
               </a:lnSpc>
               <a:buNone/>
             </a:pPr>
             <a:r>
-              <a:rPr lang="en-US" sz="1200" dirty="0">
+              <a:rPr lang="en-US" sz="1600" b="1" dirty="0">
                 <a:solidFill>
                   <a:srgbClr val="1C2E22"/>
+                </a:solidFill>
+                <a:latin typeface="Georgia" pitchFamily="34" charset="0"/>
+                <a:ea typeface="Georgia" pitchFamily="34" charset="-122"/>
+                <a:cs typeface="Georgia" pitchFamily="34" charset="-120"/>
+              </a:rPr>
+              <a:t>Orders cluster on Sunday and Monday, roughly 9:00 to 16:00 — and fall away sharply outside daytime hours.</a:t>
+            </a:r>
+            <a:endParaRPr lang="en-US" sz="1150" dirty="0"/>
+          </a:p>
+        </p:txBody>
+      </p:sp>
+      <p:sp>
+        <p:nvSpPr>
+          <p:cNvPr id="7" name="Text 4"/>
+          <p:cNvSpPr/>
+          <p:nvPr/>
+        </p:nvSpPr>
+        <p:spPr>
+          <a:xfrm>
+            <a:off x="777240" y="6455664"/>
+            <a:ext cx="7315200" cy="274320"/>
+          </a:xfrm>
+          <a:prstGeom prst="rect">
+            <a:avLst/>
+          </a:prstGeom>
+          <a:noFill/>
+          <a:ln/>
+        </p:spPr>
+        <p:txBody>
+          <a:bodyPr wrap="square" lIns="0" tIns="0" rIns="0" bIns="0" rtlCol="0" anchor="ctr"/>
+          <a:lstStyle/>
+          <a:p>
+            <a:pPr algn="l" indent="0" marL="0">
+              <a:buNone/>
+            </a:pPr>
+            <a:r>
+              <a:rPr lang="en-US" sz="900" dirty="0">
+                <a:solidFill>
+                  <a:srgbClr val="6B7A6E"/>
                 </a:solidFill>
                 <a:latin typeface="Calibri" pitchFamily="34" charset="0"/>
                 <a:ea typeface="Calibri" pitchFamily="34" charset="-122"/>
                 <a:cs typeface="Calibri" pitchFamily="34" charset="-120"/>
               </a:rPr>
-              <a:t>Orders cluster on Sunday and Monday, roughly 9:00–16:00, and fall away sharply before 7:00 and after 19:00.
-</a:t>
-            </a:r>
-            <a:pPr indent="0" marL="0">
-              <a:lnSpc>
-                <a:spcPts val="1600"/>
-              </a:lnSpc>
-              <a:buNone/>
-            </a:pPr>
-            <a:r>
-              <a:rPr lang="en-US" sz="1050" b="1" spc="150" kern="0" dirty="0">
-                <a:solidFill>
-                  <a:srgbClr val="E07A3F"/>
-                </a:solidFill>
-                <a:latin typeface="Calibri" pitchFamily="34" charset="0"/>
-                <a:ea typeface="Calibri" pitchFamily="34" charset="-122"/>
-                <a:cs typeface="Calibri" pitchFamily="34" charset="-120"/>
-              </a:rPr>
-              <a:t>RECOMMENDATION   </a:t>
-            </a:r>
-            <a:pPr indent="0" marL="0">
-              <a:lnSpc>
-                <a:spcPts val="1600"/>
-              </a:lnSpc>
-              <a:buNone/>
-            </a:pPr>
-            <a:r>
-              <a:rPr lang="en-US" sz="1200" dirty="0">
-                <a:solidFill>
-                  <a:srgbClr val="1C2E22"/>
-                </a:solidFill>
-                <a:latin typeface="Calibri" pitchFamily="34" charset="0"/>
-                <a:ea typeface="Calibri" pitchFamily="34" charset="-122"/>
-                <a:cs typeface="Calibri" pitchFamily="34" charset="-120"/>
-              </a:rPr>
-              <a:t>Staff up for the weekly peak; push promotions on Saturday evening to catch early planners.</a:t>
-            </a:r>
-            <a:endParaRPr lang="en-US" sz="1050" dirty="0"/>
+              <a:t>Grocery Product Placement Analysis  ·  Group 11</a:t>
+            </a:r>
+            <a:endParaRPr lang="en-US" sz="900" dirty="0"/>
           </a:p>
         </p:txBody>
       </p:sp>
       <p:sp>
         <p:nvSpPr>
           <p:cNvPr id="8" name="Text 5"/>
-          <p:cNvSpPr/>
-          <p:nvPr/>
-        </p:nvSpPr>
-        <p:spPr>
-          <a:xfrm>
-            <a:off x="777240" y="6455664"/>
-            <a:ext cx="7315200" cy="274320"/>
-          </a:xfrm>
-          <a:prstGeom prst="rect">
-            <a:avLst/>
-          </a:prstGeom>
-          <a:noFill/>
-          <a:ln/>
-        </p:spPr>
-        <p:txBody>
-          <a:bodyPr wrap="square" lIns="0" tIns="0" rIns="0" bIns="0" rtlCol="0" anchor="ctr"/>
-          <a:lstStyle/>
-          <a:p>
-            <a:pPr algn="l" indent="0" marL="0">
-              <a:buNone/>
-            </a:pPr>
-            <a:r>
-              <a:rPr lang="en-US" sz="900" dirty="0">
-                <a:solidFill>
-                  <a:srgbClr val="6B7A6E"/>
-                </a:solidFill>
-                <a:latin typeface="Calibri" pitchFamily="34" charset="0"/>
-                <a:ea typeface="Calibri" pitchFamily="34" charset="-122"/>
-                <a:cs typeface="Calibri" pitchFamily="34" charset="-120"/>
-              </a:rPr>
-              <a:t>Grocery Product Placement Analysis  ·  Group 11</a:t>
-            </a:r>
-            <a:endParaRPr lang="en-US" sz="900" dirty="0"/>
-          </a:p>
-        </p:txBody>
-      </p:sp>
-      <p:sp>
-        <p:nvSpPr>
-          <p:cNvPr id="9" name="Text 6"/>
           <p:cNvSpPr/>
           <p:nvPr/>
         </p:nvSpPr>
@@ -3781,8 +3580,8 @@
         </p:nvSpPr>
         <p:spPr>
           <a:xfrm>
-            <a:off x="777240" y="1874520"/>
-            <a:ext cx="2615184" cy="4160520"/>
+            <a:off x="777240" y="1920240"/>
+            <a:ext cx="2615184" cy="3977640"/>
           </a:xfrm>
           <a:prstGeom prst="roundRect">
             <a:avLst>
@@ -3815,7 +3614,7 @@
         </p:nvSpPr>
         <p:spPr>
           <a:xfrm>
-            <a:off x="777240" y="1874520"/>
+            <a:off x="777240" y="1920240"/>
             <a:ext cx="2615184" cy="100584"/>
           </a:xfrm>
           <a:prstGeom prst="rect">
@@ -3835,7 +3634,7 @@
         </p:nvSpPr>
         <p:spPr>
           <a:xfrm>
-            <a:off x="1069848" y="2148840"/>
+            <a:off x="1069848" y="2240280"/>
             <a:ext cx="2011680" cy="640080"/>
           </a:xfrm>
           <a:prstGeom prst="rect">
@@ -3874,8 +3673,8 @@
         </p:nvSpPr>
         <p:spPr>
           <a:xfrm>
-            <a:off x="1069848" y="2880360"/>
-            <a:ext cx="2057400" cy="777240"/>
+            <a:off x="1069848" y="2971800"/>
+            <a:ext cx="2103120" cy="822960"/>
           </a:xfrm>
           <a:prstGeom prst="rect">
             <a:avLst/>
@@ -3889,12 +3688,12 @@
           <a:p>
             <a:pPr indent="0" marL="0">
               <a:lnSpc>
-                <a:spcPts val="2100"/>
+                <a:spcPts val="2200"/>
               </a:lnSpc>
               <a:buNone/>
             </a:pPr>
             <a:r>
-              <a:rPr lang="en-US" sz="1800" b="1" dirty="0">
+              <a:rPr lang="en-US" sz="1900" b="1" dirty="0">
                 <a:solidFill>
                   <a:srgbClr val="1C2E22"/>
                 </a:solidFill>
@@ -3904,7 +3703,7 @@
               </a:rPr>
               <a:t>Build on fresh</a:t>
             </a:r>
-            <a:endParaRPr lang="en-US" sz="1800" dirty="0"/>
+            <a:endParaRPr lang="en-US" sz="1900" dirty="0"/>
           </a:p>
         </p:txBody>
       </p:sp>
@@ -3916,8 +3715,8 @@
         </p:nvSpPr>
         <p:spPr>
           <a:xfrm>
-            <a:off x="1069848" y="3657600"/>
-            <a:ext cx="2057400" cy="1554480"/>
+            <a:off x="1069848" y="3886200"/>
+            <a:ext cx="2103120" cy="1280160"/>
           </a:xfrm>
           <a:prstGeom prst="rect">
             <a:avLst/>
@@ -3931,12 +3730,12 @@
           <a:p>
             <a:pPr indent="0" marL="0">
               <a:lnSpc>
-                <a:spcPts val="1700"/>
+                <a:spcPts val="1800"/>
               </a:lnSpc>
               <a:buNone/>
             </a:pPr>
             <a:r>
-              <a:rPr lang="en-US" sz="1250" dirty="0">
+              <a:rPr lang="en-US" sz="1350" dirty="0">
                 <a:solidFill>
                   <a:srgbClr val="1C2E22"/>
                 </a:solidFill>
@@ -3944,9 +3743,9 @@
                 <a:ea typeface="Calibri" pitchFamily="34" charset="-122"/>
                 <a:cs typeface="Calibri" pitchFamily="34" charset="-120"/>
               </a:rPr>
-              <a:t>Make produce and a credible organic range the non-negotiable core of the assortment.</a:t>
-            </a:r>
-            <a:endParaRPr lang="en-US" sz="1250" dirty="0"/>
+              <a:t>Produce and organic are the core.</a:t>
+            </a:r>
+            <a:endParaRPr lang="en-US" sz="1350" dirty="0"/>
           </a:p>
         </p:txBody>
       </p:sp>
@@ -3958,8 +3757,8 @@
         </p:nvSpPr>
         <p:spPr>
           <a:xfrm>
-            <a:off x="1069848" y="5532120"/>
-            <a:ext cx="2057400" cy="292608"/>
+            <a:off x="1069848" y="5440680"/>
+            <a:ext cx="2103120" cy="292608"/>
           </a:xfrm>
           <a:prstGeom prst="rect">
             <a:avLst/>
@@ -3997,8 +3796,8 @@
         </p:nvSpPr>
         <p:spPr>
           <a:xfrm>
-            <a:off x="3557016" y="1874520"/>
-            <a:ext cx="2615184" cy="4160520"/>
+            <a:off x="3557016" y="1920240"/>
+            <a:ext cx="2615184" cy="3977640"/>
           </a:xfrm>
           <a:prstGeom prst="roundRect">
             <a:avLst>
@@ -4031,7 +3830,7 @@
         </p:nvSpPr>
         <p:spPr>
           <a:xfrm>
-            <a:off x="3557016" y="1874520"/>
+            <a:off x="3557016" y="1920240"/>
             <a:ext cx="2615184" cy="100584"/>
           </a:xfrm>
           <a:prstGeom prst="rect">
@@ -4051,7 +3850,7 @@
         </p:nvSpPr>
         <p:spPr>
           <a:xfrm>
-            <a:off x="3849624" y="2148840"/>
+            <a:off x="3849624" y="2240280"/>
             <a:ext cx="2011680" cy="640080"/>
           </a:xfrm>
           <a:prstGeom prst="rect">
@@ -4090,8 +3889,8 @@
         </p:nvSpPr>
         <p:spPr>
           <a:xfrm>
-            <a:off x="3849624" y="2880360"/>
-            <a:ext cx="2057400" cy="777240"/>
+            <a:off x="3849624" y="2971800"/>
+            <a:ext cx="2103120" cy="822960"/>
           </a:xfrm>
           <a:prstGeom prst="rect">
             <a:avLst/>
@@ -4105,12 +3904,12 @@
           <a:p>
             <a:pPr indent="0" marL="0">
               <a:lnSpc>
-                <a:spcPts val="2100"/>
+                <a:spcPts val="2200"/>
               </a:lnSpc>
               <a:buNone/>
             </a:pPr>
             <a:r>
-              <a:rPr lang="en-US" sz="1800" b="1" dirty="0">
+              <a:rPr lang="en-US" sz="1900" b="1" dirty="0">
                 <a:solidFill>
                   <a:srgbClr val="1C2E22"/>
                 </a:solidFill>
@@ -4120,7 +3919,7 @@
               </a:rPr>
               <a:t>Bundle the clusters</a:t>
             </a:r>
-            <a:endParaRPr lang="en-US" sz="1800" dirty="0"/>
+            <a:endParaRPr lang="en-US" sz="1900" dirty="0"/>
           </a:p>
         </p:txBody>
       </p:sp>
@@ -4132,8 +3931,8 @@
         </p:nvSpPr>
         <p:spPr>
           <a:xfrm>
-            <a:off x="3849624" y="3657600"/>
-            <a:ext cx="2057400" cy="1554480"/>
+            <a:off x="3849624" y="3886200"/>
+            <a:ext cx="2103120" cy="1280160"/>
           </a:xfrm>
           <a:prstGeom prst="rect">
             <a:avLst/>
@@ -4147,12 +3946,12 @@
           <a:p>
             <a:pPr indent="0" marL="0">
               <a:lnSpc>
-                <a:spcPts val="1700"/>
+                <a:spcPts val="1800"/>
               </a:lnSpc>
               <a:buNone/>
             </a:pPr>
             <a:r>
-              <a:rPr lang="en-US" sz="1250" dirty="0">
+              <a:rPr lang="en-US" sz="1350" dirty="0">
                 <a:solidFill>
                   <a:srgbClr val="1C2E22"/>
                 </a:solidFill>
@@ -4160,9 +3959,9 @@
                 <a:ea typeface="Calibri" pitchFamily="34" charset="-122"/>
                 <a:cs typeface="Calibri" pitchFamily="34" charset="-120"/>
               </a:rPr>
-              <a:t>Group co-purchased products together and cross-sell across the strongest links.</a:t>
-            </a:r>
-            <a:endParaRPr lang="en-US" sz="1250" dirty="0"/>
+              <a:t>Group and cross-sell what sells together.</a:t>
+            </a:r>
+            <a:endParaRPr lang="en-US" sz="1350" dirty="0"/>
           </a:p>
         </p:txBody>
       </p:sp>
@@ -4174,8 +3973,8 @@
         </p:nvSpPr>
         <p:spPr>
           <a:xfrm>
-            <a:off x="3849624" y="5532120"/>
-            <a:ext cx="2057400" cy="292608"/>
+            <a:off x="3849624" y="5440680"/>
+            <a:ext cx="2103120" cy="292608"/>
           </a:xfrm>
           <a:prstGeom prst="rect">
             <a:avLst/>
@@ -4213,8 +4012,8 @@
         </p:nvSpPr>
         <p:spPr>
           <a:xfrm>
-            <a:off x="6336792" y="1874520"/>
-            <a:ext cx="2615184" cy="4160520"/>
+            <a:off x="6336792" y="1920240"/>
+            <a:ext cx="2615184" cy="3977640"/>
           </a:xfrm>
           <a:prstGeom prst="roundRect">
             <a:avLst>
@@ -4247,7 +4046,7 @@
         </p:nvSpPr>
         <p:spPr>
           <a:xfrm>
-            <a:off x="6336792" y="1874520"/>
+            <a:off x="6336792" y="1920240"/>
             <a:ext cx="2615184" cy="100584"/>
           </a:xfrm>
           <a:prstGeom prst="rect">
@@ -4267,7 +4066,7 @@
         </p:nvSpPr>
         <p:spPr>
           <a:xfrm>
-            <a:off x="6629400" y="2148840"/>
+            <a:off x="6629400" y="2240280"/>
             <a:ext cx="2011680" cy="640080"/>
           </a:xfrm>
           <a:prstGeom prst="rect">
@@ -4306,8 +4105,8 @@
         </p:nvSpPr>
         <p:spPr>
           <a:xfrm>
-            <a:off x="6629400" y="2880360"/>
-            <a:ext cx="2057400" cy="777240"/>
+            <a:off x="6629400" y="2971800"/>
+            <a:ext cx="2103120" cy="822960"/>
           </a:xfrm>
           <a:prstGeom prst="rect">
             <a:avLst/>
@@ -4321,12 +4120,12 @@
           <a:p>
             <a:pPr indent="0" marL="0">
               <a:lnSpc>
-                <a:spcPts val="2100"/>
+                <a:spcPts val="2200"/>
               </a:lnSpc>
               <a:buNone/>
             </a:pPr>
             <a:r>
-              <a:rPr lang="en-US" sz="1800" b="1" dirty="0">
+              <a:rPr lang="en-US" sz="1900" b="1" dirty="0">
                 <a:solidFill>
                   <a:srgbClr val="1C2E22"/>
                 </a:solidFill>
@@ -4336,7 +4135,7 @@
               </a:rPr>
               <a:t>Subscribe the staples</a:t>
             </a:r>
-            <a:endParaRPr lang="en-US" sz="1800" dirty="0"/>
+            <a:endParaRPr lang="en-US" sz="1900" dirty="0"/>
           </a:p>
         </p:txBody>
       </p:sp>
@@ -4348,8 +4147,8 @@
         </p:nvSpPr>
         <p:spPr>
           <a:xfrm>
-            <a:off x="6629400" y="3657600"/>
-            <a:ext cx="2057400" cy="1554480"/>
+            <a:off x="6629400" y="3886200"/>
+            <a:ext cx="2103120" cy="1280160"/>
           </a:xfrm>
           <a:prstGeom prst="rect">
             <a:avLst/>
@@ -4363,12 +4162,12 @@
           <a:p>
             <a:pPr indent="0" marL="0">
               <a:lnSpc>
-                <a:spcPts val="1700"/>
+                <a:spcPts val="1800"/>
               </a:lnSpc>
               <a:buNone/>
             </a:pPr>
             <a:r>
-              <a:rPr lang="en-US" sz="1250" dirty="0">
+              <a:rPr lang="en-US" sz="1350" dirty="0">
                 <a:solidFill>
                   <a:srgbClr val="1C2E22"/>
                 </a:solidFill>
@@ -4376,9 +4175,9 @@
                 <a:ea typeface="Calibri" pitchFamily="34" charset="-122"/>
                 <a:cs typeface="Calibri" pitchFamily="34" charset="-120"/>
               </a:rPr>
-              <a:t>Offer milk, water and other high-reorder staples as subscriptions and auto-reorders.</a:t>
-            </a:r>
-            <a:endParaRPr lang="en-US" sz="1250" dirty="0"/>
+              <a:t>Milk and water — auto-reorder offers.</a:t>
+            </a:r>
+            <a:endParaRPr lang="en-US" sz="1350" dirty="0"/>
           </a:p>
         </p:txBody>
       </p:sp>
@@ -4390,8 +4189,8 @@
         </p:nvSpPr>
         <p:spPr>
           <a:xfrm>
-            <a:off x="6629400" y="5532120"/>
-            <a:ext cx="2057400" cy="292608"/>
+            <a:off x="6629400" y="5440680"/>
+            <a:ext cx="2103120" cy="292608"/>
           </a:xfrm>
           <a:prstGeom prst="rect">
             <a:avLst/>
@@ -4429,8 +4228,8 @@
         </p:nvSpPr>
         <p:spPr>
           <a:xfrm>
-            <a:off x="9116568" y="1874520"/>
-            <a:ext cx="2615184" cy="4160520"/>
+            <a:off x="9116568" y="1920240"/>
+            <a:ext cx="2615184" cy="3977640"/>
           </a:xfrm>
           <a:prstGeom prst="roundRect">
             <a:avLst>
@@ -4463,7 +4262,7 @@
         </p:nvSpPr>
         <p:spPr>
           <a:xfrm>
-            <a:off x="9116568" y="1874520"/>
+            <a:off x="9116568" y="1920240"/>
             <a:ext cx="2615184" cy="100584"/>
           </a:xfrm>
           <a:prstGeom prst="rect">
@@ -4483,7 +4282,7 @@
         </p:nvSpPr>
         <p:spPr>
           <a:xfrm>
-            <a:off x="9409176" y="2148840"/>
+            <a:off x="9409176" y="2240280"/>
             <a:ext cx="2011680" cy="640080"/>
           </a:xfrm>
           <a:prstGeom prst="rect">
@@ -4522,8 +4321,8 @@
         </p:nvSpPr>
         <p:spPr>
           <a:xfrm>
-            <a:off x="9409176" y="2880360"/>
-            <a:ext cx="2057400" cy="777240"/>
+            <a:off x="9409176" y="2971800"/>
+            <a:ext cx="2103120" cy="822960"/>
           </a:xfrm>
           <a:prstGeom prst="rect">
             <a:avLst/>
@@ -4537,12 +4336,12 @@
           <a:p>
             <a:pPr indent="0" marL="0">
               <a:lnSpc>
-                <a:spcPts val="2100"/>
+                <a:spcPts val="2200"/>
               </a:lnSpc>
               <a:buNone/>
             </a:pPr>
             <a:r>
-              <a:rPr lang="en-US" sz="1800" b="1" dirty="0">
+              <a:rPr lang="en-US" sz="1900" b="1" dirty="0">
                 <a:solidFill>
                   <a:srgbClr val="1C2E22"/>
                 </a:solidFill>
@@ -4552,7 +4351,7 @@
               </a:rPr>
               <a:t>Protect the gems</a:t>
             </a:r>
-            <a:endParaRPr lang="en-US" sz="1800" dirty="0"/>
+            <a:endParaRPr lang="en-US" sz="1900" dirty="0"/>
           </a:p>
         </p:txBody>
       </p:sp>
@@ -4564,8 +4363,8 @@
         </p:nvSpPr>
         <p:spPr>
           <a:xfrm>
-            <a:off x="9409176" y="3657600"/>
-            <a:ext cx="2057400" cy="1554480"/>
+            <a:off x="9409176" y="3886200"/>
+            <a:ext cx="2103120" cy="1280160"/>
           </a:xfrm>
           <a:prstGeom prst="rect">
             <a:avLst/>
@@ -4579,12 +4378,12 @@
           <a:p>
             <a:pPr indent="0" marL="0">
               <a:lnSpc>
-                <a:spcPts val="1700"/>
+                <a:spcPts val="1800"/>
               </a:lnSpc>
               <a:buNone/>
             </a:pPr>
             <a:r>
-              <a:rPr lang="en-US" sz="1250" dirty="0">
+              <a:rPr lang="en-US" sz="1350" dirty="0">
                 <a:solidFill>
                   <a:srgbClr val="1C2E22"/>
                 </a:solidFill>
@@ -4592,9 +4391,9 @@
                 <a:ea typeface="Calibri" pitchFamily="34" charset="-122"/>
                 <a:cs typeface="Calibri" pitchFamily="34" charset="-120"/>
               </a:rPr>
-              <a:t>Keep loyal niche products on the shelf — they retain customers despite low volume.</a:t>
-            </a:r>
-            <a:endParaRPr lang="en-US" sz="1250" dirty="0"/>
+              <a:t>Keep loyal niche products on the shelf.</a:t>
+            </a:r>
+            <a:endParaRPr lang="en-US" sz="1350" dirty="0"/>
           </a:p>
         </p:txBody>
       </p:sp>
@@ -4606,8 +4405,8 @@
         </p:nvSpPr>
         <p:spPr>
           <a:xfrm>
-            <a:off x="9409176" y="5532120"/>
-            <a:ext cx="2057400" cy="292608"/>
+            <a:off x="9409176" y="5440680"/>
+            <a:ext cx="2103120" cy="292608"/>
           </a:xfrm>
           <a:prstGeom prst="rect">
             <a:avLst/>
@@ -4884,7 +4683,7 @@
                 <a:ea typeface="Calibri" pitchFamily="34" charset="-122"/>
                 <a:cs typeface="Calibri" pitchFamily="34" charset="-120"/>
               </a:rPr>
-              <a:t>The dashboard turns anonymised purchase data into decisions Sandra and Marco can act on — faster, more intuitively, and without writing a line of code.</a:t>
+              <a:t>Anonymised purchase data, turned into decisions Sandra and Marco can act on — without writing a line of code.</a:t>
             </a:r>
             <a:endParaRPr lang="en-US" sz="1500" dirty="0"/>
           </a:p>
@@ -5851,7 +5650,7 @@
         <p:spPr>
           <a:xfrm>
             <a:off x="777240" y="868680"/>
-            <a:ext cx="6400800" cy="914400"/>
+            <a:ext cx="7680960" cy="914400"/>
           </a:xfrm>
           <a:prstGeom prst="rect">
             <a:avLst/>
@@ -5906,8 +5705,8 @@
         </p:nvSpPr>
         <p:spPr>
           <a:xfrm>
-            <a:off x="777240" y="2514600"/>
-            <a:ext cx="5074920" cy="3017520"/>
+            <a:off x="777240" y="2880360"/>
+            <a:ext cx="5029200" cy="1828800"/>
           </a:xfrm>
           <a:prstGeom prst="rect">
             <a:avLst/>
@@ -5921,45 +5720,62 @@
           <a:p>
             <a:pPr indent="0" marL="0">
               <a:lnSpc>
-                <a:spcPts val="2200"/>
+                <a:spcPts val="3200"/>
               </a:lnSpc>
-              <a:spcAft>
-                <a:spcPts val="1000"/>
-              </a:spcAft>
-              <a:buNone/>
-            </a:pPr>
-            <a:r>
-              <a:rPr lang="en-US" sz="1500" dirty="0">
-                <a:solidFill>
-                  <a:srgbClr val="1C2E22"/>
-                </a:solidFill>
-                <a:latin typeface="Calibri" pitchFamily="34" charset="0"/>
-                <a:ea typeface="Calibri" pitchFamily="34" charset="-122"/>
-                <a:cs typeface="Calibri" pitchFamily="34" charset="-120"/>
-              </a:rPr>
-              <a:t>Quick-commerce platforms like Flink or Gorillas manage thousands of products and have to keep optimising what they stock — balancing customer demand, storage capacity and delivery efficiency.</a:t>
-            </a:r>
-            <a:endParaRPr lang="en-US" sz="1500" dirty="0"/>
+              <a:buNone/>
+            </a:pPr>
+            <a:r>
+              <a:rPr lang="en-US" sz="2200" dirty="0">
+                <a:solidFill>
+                  <a:srgbClr val="2F6E4F"/>
+                </a:solidFill>
+                <a:latin typeface="Georgia" pitchFamily="34" charset="0"/>
+                <a:ea typeface="Georgia" pitchFamily="34" charset="-122"/>
+                <a:cs typeface="Georgia" pitchFamily="34" charset="-120"/>
+              </a:rPr>
+              <a:t>Thousands of products.</a:t>
+            </a:r>
+            <a:endParaRPr lang="en-US" sz="2200" dirty="0"/>
           </a:p>
           <a:p>
             <a:pPr indent="0" marL="0">
               <a:lnSpc>
-                <a:spcPts val="2200"/>
+                <a:spcPts val="3200"/>
               </a:lnSpc>
               <a:buNone/>
             </a:pPr>
             <a:r>
-              <a:rPr lang="en-US" sz="1500" dirty="0">
-                <a:solidFill>
-                  <a:srgbClr val="1C2E22"/>
-                </a:solidFill>
-                <a:latin typeface="Calibri" pitchFamily="34" charset="0"/>
-                <a:ea typeface="Calibri" pitchFamily="34" charset="-122"/>
-                <a:cs typeface="Calibri" pitchFamily="34" charset="-120"/>
-              </a:rPr>
-              <a:t>Assortment planners and buyers make these calls every week, often from manual Excel reports. They need a faster, more intuitive, data-driven foundation — and that is what this project set out to build.</a:t>
-            </a:r>
-            <a:endParaRPr lang="en-US" sz="1500" dirty="0"/>
+              <a:rPr lang="en-US" sz="2200" dirty="0">
+                <a:solidFill>
+                  <a:srgbClr val="2F6E4F"/>
+                </a:solidFill>
+                <a:latin typeface="Georgia" pitchFamily="34" charset="0"/>
+                <a:ea typeface="Georgia" pitchFamily="34" charset="-122"/>
+                <a:cs typeface="Georgia" pitchFamily="34" charset="-120"/>
+              </a:rPr>
+              <a:t>Weekly stocking decisions.</a:t>
+            </a:r>
+            <a:endParaRPr lang="en-US" sz="2200" dirty="0"/>
+          </a:p>
+          <a:p>
+            <a:pPr indent="0" marL="0">
+              <a:lnSpc>
+                <a:spcPts val="3200"/>
+              </a:lnSpc>
+              <a:buNone/>
+            </a:pPr>
+            <a:r>
+              <a:rPr lang="en-US" sz="2200" dirty="0">
+                <a:solidFill>
+                  <a:srgbClr val="2F6E4F"/>
+                </a:solidFill>
+                <a:latin typeface="Georgia" pitchFamily="34" charset="0"/>
+                <a:ea typeface="Georgia" pitchFamily="34" charset="-122"/>
+                <a:cs typeface="Georgia" pitchFamily="34" charset="-120"/>
+              </a:rPr>
+              <a:t>Today — mostly intuition.</a:t>
+            </a:r>
+            <a:endParaRPr lang="en-US" sz="2200" dirty="0"/>
           </a:p>
         </p:txBody>
       </p:sp>
@@ -6637,12 +6453,12 @@
         </p:nvSpPr>
         <p:spPr>
           <a:xfrm>
-            <a:off x="777240" y="1874520"/>
-            <a:ext cx="2542032" cy="1691640"/>
+            <a:off x="777240" y="2057400"/>
+            <a:ext cx="2542032" cy="1783080"/>
           </a:xfrm>
           <a:prstGeom prst="roundRect">
             <a:avLst>
-              <a:gd name="adj" fmla="val 4324"/>
+              <a:gd name="adj" fmla="val 4103"/>
             </a:avLst>
           </a:prstGeom>
           <a:solidFill>
@@ -6671,8 +6487,8 @@
         </p:nvSpPr>
         <p:spPr>
           <a:xfrm>
-            <a:off x="777240" y="2084832"/>
-            <a:ext cx="2542032" cy="868680"/>
+            <a:off x="777240" y="2304288"/>
+            <a:ext cx="2542032" cy="914400"/>
           </a:xfrm>
           <a:prstGeom prst="rect">
             <a:avLst/>
@@ -6710,7 +6526,7 @@
         </p:nvSpPr>
         <p:spPr>
           <a:xfrm>
-            <a:off x="914400" y="2944368"/>
+            <a:off x="914400" y="3200400"/>
             <a:ext cx="2267712" cy="502920"/>
           </a:xfrm>
           <a:prstGeom prst="rect">
@@ -6749,12 +6565,12 @@
         </p:nvSpPr>
         <p:spPr>
           <a:xfrm>
-            <a:off x="3474720" y="1874520"/>
-            <a:ext cx="2542032" cy="1691640"/>
+            <a:off x="3474720" y="2057400"/>
+            <a:ext cx="2542032" cy="1783080"/>
           </a:xfrm>
           <a:prstGeom prst="roundRect">
             <a:avLst>
-              <a:gd name="adj" fmla="val 4324"/>
+              <a:gd name="adj" fmla="val 4103"/>
             </a:avLst>
           </a:prstGeom>
           <a:solidFill>
@@ -6783,8 +6599,8 @@
         </p:nvSpPr>
         <p:spPr>
           <a:xfrm>
-            <a:off x="3474720" y="2084832"/>
-            <a:ext cx="2542032" cy="868680"/>
+            <a:off x="3474720" y="2304288"/>
+            <a:ext cx="2542032" cy="914400"/>
           </a:xfrm>
           <a:prstGeom prst="rect">
             <a:avLst/>
@@ -6822,7 +6638,7 @@
         </p:nvSpPr>
         <p:spPr>
           <a:xfrm>
-            <a:off x="3611880" y="2944368"/>
+            <a:off x="3611880" y="3200400"/>
             <a:ext cx="2267712" cy="502920"/>
           </a:xfrm>
           <a:prstGeom prst="rect">
@@ -6861,12 +6677,12 @@
         </p:nvSpPr>
         <p:spPr>
           <a:xfrm>
-            <a:off x="6172200" y="1874520"/>
-            <a:ext cx="2542032" cy="1691640"/>
+            <a:off x="6172200" y="2057400"/>
+            <a:ext cx="2542032" cy="1783080"/>
           </a:xfrm>
           <a:prstGeom prst="roundRect">
             <a:avLst>
-              <a:gd name="adj" fmla="val 4324"/>
+              <a:gd name="adj" fmla="val 4103"/>
             </a:avLst>
           </a:prstGeom>
           <a:solidFill>
@@ -6895,8 +6711,8 @@
         </p:nvSpPr>
         <p:spPr>
           <a:xfrm>
-            <a:off x="6172200" y="2084832"/>
-            <a:ext cx="2542032" cy="868680"/>
+            <a:off x="6172200" y="2304288"/>
+            <a:ext cx="2542032" cy="914400"/>
           </a:xfrm>
           <a:prstGeom prst="rect">
             <a:avLst/>
@@ -6934,7 +6750,7 @@
         </p:nvSpPr>
         <p:spPr>
           <a:xfrm>
-            <a:off x="6309360" y="2944368"/>
+            <a:off x="6309360" y="3200400"/>
             <a:ext cx="2267712" cy="502920"/>
           </a:xfrm>
           <a:prstGeom prst="rect">
@@ -6973,12 +6789,12 @@
         </p:nvSpPr>
         <p:spPr>
           <a:xfrm>
-            <a:off x="8869680" y="1874520"/>
-            <a:ext cx="2542032" cy="1691640"/>
+            <a:off x="8869680" y="2057400"/>
+            <a:ext cx="2542032" cy="1783080"/>
           </a:xfrm>
           <a:prstGeom prst="roundRect">
             <a:avLst>
-              <a:gd name="adj" fmla="val 4324"/>
+              <a:gd name="adj" fmla="val 4103"/>
             </a:avLst>
           </a:prstGeom>
           <a:solidFill>
@@ -7007,8 +6823,8 @@
         </p:nvSpPr>
         <p:spPr>
           <a:xfrm>
-            <a:off x="8869680" y="2084832"/>
-            <a:ext cx="2542032" cy="868680"/>
+            <a:off x="8869680" y="2304288"/>
+            <a:ext cx="2542032" cy="914400"/>
           </a:xfrm>
           <a:prstGeom prst="rect">
             <a:avLst/>
@@ -7046,7 +6862,7 @@
         </p:nvSpPr>
         <p:spPr>
           <a:xfrm>
-            <a:off x="9006840" y="2944368"/>
+            <a:off x="9006840" y="3200400"/>
             <a:ext cx="2267712" cy="502920"/>
           </a:xfrm>
           <a:prstGeom prst="rect">
@@ -7085,158 +6901,79 @@
         </p:nvSpPr>
         <p:spPr>
           <a:xfrm>
-            <a:off x="777240" y="3977640"/>
-            <a:ext cx="10607040" cy="914400"/>
-          </a:xfrm>
-          <a:prstGeom prst="rect">
-            <a:avLst/>
-          </a:prstGeom>
-          <a:noFill/>
-          <a:ln/>
-        </p:spPr>
-        <p:txBody>
-          <a:bodyPr wrap="square" lIns="0" tIns="0" rIns="0" bIns="0" rtlCol="0" anchor="t"/>
-          <a:lstStyle/>
-          <a:p>
-            <a:pPr indent="0" marL="0">
-              <a:lnSpc>
-                <a:spcPts val="2100"/>
-              </a:lnSpc>
-              <a:buNone/>
-            </a:pPr>
-            <a:r>
-              <a:rPr lang="en-US" sz="1400" b="1" dirty="0">
+            <a:off x="777240" y="4434840"/>
+            <a:ext cx="10607040" cy="457200"/>
+          </a:xfrm>
+          <a:prstGeom prst="rect">
+            <a:avLst/>
+          </a:prstGeom>
+          <a:noFill/>
+          <a:ln/>
+        </p:spPr>
+        <p:txBody>
+          <a:bodyPr wrap="square" lIns="0" tIns="0" rIns="0" bIns="0" rtlCol="0" anchor="ctr"/>
+          <a:lstStyle/>
+          <a:p>
+            <a:pPr algn="l" indent="0" marL="0">
+              <a:buNone/>
+            </a:pPr>
+            <a:r>
+              <a:rPr lang="en-US" sz="1800" dirty="0">
                 <a:solidFill>
                   <a:srgbClr val="1C2E22"/>
+                </a:solidFill>
+                <a:latin typeface="Georgia" pitchFamily="34" charset="0"/>
+                <a:ea typeface="Georgia" pitchFamily="34" charset="-122"/>
+                <a:cs typeface="Georgia" pitchFamily="34" charset="-120"/>
+              </a:rPr>
+              <a:t>The public Instacart 2017 dataset — six linked tables, fully anonymised.</a:t>
+            </a:r>
+            <a:endParaRPr lang="en-US" sz="1800" dirty="0"/>
+          </a:p>
+        </p:txBody>
+      </p:sp>
+      <p:sp>
+        <p:nvSpPr>
+          <p:cNvPr id="17" name="Text 15"/>
+          <p:cNvSpPr/>
+          <p:nvPr/>
+        </p:nvSpPr>
+        <p:spPr>
+          <a:xfrm>
+            <a:off x="777240" y="6455664"/>
+            <a:ext cx="7315200" cy="274320"/>
+          </a:xfrm>
+          <a:prstGeom prst="rect">
+            <a:avLst/>
+          </a:prstGeom>
+          <a:noFill/>
+          <a:ln/>
+        </p:spPr>
+        <p:txBody>
+          <a:bodyPr wrap="square" lIns="0" tIns="0" rIns="0" bIns="0" rtlCol="0" anchor="ctr"/>
+          <a:lstStyle/>
+          <a:p>
+            <a:pPr algn="l" indent="0" marL="0">
+              <a:buNone/>
+            </a:pPr>
+            <a:r>
+              <a:rPr lang="en-US" sz="900" dirty="0">
+                <a:solidFill>
+                  <a:srgbClr val="6B7A6E"/>
                 </a:solidFill>
                 <a:latin typeface="Calibri" pitchFamily="34" charset="0"/>
                 <a:ea typeface="Calibri" pitchFamily="34" charset="-122"/>
                 <a:cs typeface="Calibri" pitchFamily="34" charset="-120"/>
               </a:rPr>
-              <a:t>The Instacart Online Grocery dataset (2017)  </a:t>
-            </a:r>
-            <a:pPr indent="0" marL="0">
-              <a:lnSpc>
-                <a:spcPts val="2100"/>
-              </a:lnSpc>
-              <a:buNone/>
-            </a:pPr>
-            <a:r>
-              <a:rPr lang="en-US" sz="1400" dirty="0">
-                <a:solidFill>
-                  <a:srgbClr val="1C2E22"/>
-                </a:solidFill>
-                <a:latin typeface="Calibri" pitchFamily="34" charset="0"/>
-                <a:ea typeface="Calibri" pitchFamily="34" charset="-122"/>
-                <a:cs typeface="Calibri" pitchFamily="34" charset="-120"/>
-              </a:rPr>
-              <a:t>is a public, fully anonymised set of US grocery-delivery orders. It spans six linked tables — orders, order-products, products, aisles and departments — covering roughly 3.4 million orders in total, of which 3.2 million prior orders form the basis of every chart in this deck.</a:t>
-            </a:r>
-            <a:endParaRPr lang="en-US" sz="1400" dirty="0"/>
-          </a:p>
-        </p:txBody>
-      </p:sp>
-      <p:sp>
-        <p:nvSpPr>
-          <p:cNvPr id="17" name="Text 15"/>
-          <p:cNvSpPr/>
-          <p:nvPr/>
-        </p:nvSpPr>
-        <p:spPr>
-          <a:xfrm>
-            <a:off x="777240" y="5074920"/>
-            <a:ext cx="10607040" cy="640080"/>
-          </a:xfrm>
-          <a:prstGeom prst="rect">
-            <a:avLst/>
-          </a:prstGeom>
-          <a:noFill/>
-          <a:ln/>
-        </p:spPr>
-        <p:txBody>
-          <a:bodyPr wrap="square" lIns="0" tIns="0" rIns="0" bIns="0" rtlCol="0" anchor="t"/>
-          <a:lstStyle/>
-          <a:p>
-            <a:pPr indent="0" marL="0">
-              <a:lnSpc>
-                <a:spcPts val="1800"/>
-              </a:lnSpc>
-              <a:buNone/>
-            </a:pPr>
-            <a:r>
-              <a:rPr lang="en-US" sz="1250" b="1" dirty="0">
-                <a:solidFill>
-                  <a:srgbClr val="E07A3F"/>
-                </a:solidFill>
-                <a:latin typeface="Calibri" pitchFamily="34" charset="0"/>
-                <a:ea typeface="Calibri" pitchFamily="34" charset="-122"/>
-                <a:cs typeface="Calibri" pitchFamily="34" charset="-120"/>
-              </a:rPr>
-              <a:t>Good to know   </a:t>
-            </a:r>
-            <a:pPr indent="0" marL="0">
-              <a:lnSpc>
-                <a:spcPts val="1800"/>
-              </a:lnSpc>
-              <a:buNone/>
-            </a:pPr>
-            <a:r>
-              <a:rPr lang="en-US" sz="1250" dirty="0">
-                <a:solidFill>
-                  <a:srgbClr val="6B7A6E"/>
-                </a:solidFill>
-                <a:latin typeface="Calibri" pitchFamily="34" charset="0"/>
-                <a:ea typeface="Calibri" pitchFamily="34" charset="-122"/>
-                <a:cs typeface="Calibri" pitchFamily="34" charset="-120"/>
-              </a:rPr>
-              <a:t>The data has no absolute dates (only day-of-week and hour) and reflects US shopping behaviour in 2017 — patterns, not exact forecasts.</a:t>
-            </a:r>
-            <a:endParaRPr lang="en-US" sz="1250" dirty="0"/>
+              <a:t>Grocery Product Placement Analysis  ·  Group 11</a:t>
+            </a:r>
+            <a:endParaRPr lang="en-US" sz="900" dirty="0"/>
           </a:p>
         </p:txBody>
       </p:sp>
       <p:sp>
         <p:nvSpPr>
           <p:cNvPr id="18" name="Text 16"/>
-          <p:cNvSpPr/>
-          <p:nvPr/>
-        </p:nvSpPr>
-        <p:spPr>
-          <a:xfrm>
-            <a:off x="777240" y="6455664"/>
-            <a:ext cx="7315200" cy="274320"/>
-          </a:xfrm>
-          <a:prstGeom prst="rect">
-            <a:avLst/>
-          </a:prstGeom>
-          <a:noFill/>
-          <a:ln/>
-        </p:spPr>
-        <p:txBody>
-          <a:bodyPr wrap="square" lIns="0" tIns="0" rIns="0" bIns="0" rtlCol="0" anchor="ctr"/>
-          <a:lstStyle/>
-          <a:p>
-            <a:pPr algn="l" indent="0" marL="0">
-              <a:buNone/>
-            </a:pPr>
-            <a:r>
-              <a:rPr lang="en-US" sz="900" dirty="0">
-                <a:solidFill>
-                  <a:srgbClr val="6B7A6E"/>
-                </a:solidFill>
-                <a:latin typeface="Calibri" pitchFamily="34" charset="0"/>
-                <a:ea typeface="Calibri" pitchFamily="34" charset="-122"/>
-                <a:cs typeface="Calibri" pitchFamily="34" charset="-120"/>
-              </a:rPr>
-              <a:t>Grocery Product Placement Analysis  ·  Group 11</a:t>
-            </a:r>
-            <a:endParaRPr lang="en-US" sz="900" dirty="0"/>
-          </a:p>
-        </p:txBody>
-      </p:sp>
-      <p:sp>
-        <p:nvSpPr>
-          <p:cNvPr id="19" name="Text 17"/>
           <p:cNvSpPr/>
           <p:nvPr/>
         </p:nvSpPr>
@@ -7392,11 +7129,11 @@
         <p:spPr>
           <a:xfrm>
             <a:off x="777240" y="1783080"/>
-            <a:ext cx="5029200" cy="4434840"/>
+            <a:ext cx="5029200" cy="4206240"/>
           </a:xfrm>
           <a:prstGeom prst="roundRect">
             <a:avLst>
-              <a:gd name="adj" fmla="val 1443"/>
+              <a:gd name="adj" fmla="val 1522"/>
             </a:avLst>
           </a:prstGeom>
           <a:solidFill>
@@ -7547,8 +7284,8 @@
         </p:nvSpPr>
         <p:spPr>
           <a:xfrm>
-            <a:off x="1143000" y="3291840"/>
-            <a:ext cx="4297680" cy="640080"/>
+            <a:off x="1143000" y="3310128"/>
+            <a:ext cx="4297680" cy="457200"/>
           </a:xfrm>
           <a:prstGeom prst="rect">
             <a:avLst/>
@@ -7575,7 +7312,7 @@
                 <a:ea typeface="Calibri" pitchFamily="34" charset="-122"/>
                 <a:cs typeface="Calibri" pitchFamily="34" charset="-120"/>
               </a:rPr>
-              <a:t>34 · Business Administration · 5 years in grocery retail · medium data literacy, no coding</a:t>
+              <a:t>34 · Business Administration · 5 years in grocery retail · no coding</a:t>
             </a:r>
             <a:endParaRPr lang="en-US" sz="1200" dirty="0"/>
           </a:p>
@@ -7589,8 +7326,8 @@
         </p:nvSpPr>
         <p:spPr>
           <a:xfrm>
-            <a:off x="1143000" y="4023360"/>
-            <a:ext cx="4297680" cy="1005840"/>
+            <a:off x="1143000" y="3950208"/>
+            <a:ext cx="4297680" cy="822960"/>
           </a:xfrm>
           <a:prstGeom prst="rect">
             <a:avLst/>
@@ -7604,7 +7341,7 @@
           <a:p>
             <a:pPr indent="0" marL="0">
               <a:lnSpc>
-                <a:spcPts val="1700"/>
+                <a:spcPts val="1800"/>
               </a:lnSpc>
               <a:buNone/>
             </a:pPr>
@@ -7622,12 +7359,12 @@
             </a:r>
             <a:pPr indent="0" marL="0">
               <a:lnSpc>
-                <a:spcPts val="1700"/>
+                <a:spcPts val="1800"/>
               </a:lnSpc>
               <a:buNone/>
             </a:pPr>
             <a:r>
-              <a:rPr lang="en-US" sz="1300" dirty="0">
+              <a:rPr lang="en-US" sz="1350" dirty="0">
                 <a:solidFill>
                   <a:srgbClr val="1C2E22"/>
                 </a:solidFill>
@@ -7635,7 +7372,7 @@
                 <a:ea typeface="Calibri" pitchFamily="34" charset="-122"/>
                 <a:cs typeface="Calibri" pitchFamily="34" charset="-120"/>
               </a:rPr>
-              <a:t>A fast visual overview of top products and what sells together — without manual Excel prep.</a:t>
+              <a:t>A fast visual overview of what sells — and what sells together.</a:t>
             </a:r>
             <a:endParaRPr lang="en-US" sz="1100" dirty="0"/>
           </a:p>
@@ -7649,8 +7386,8 @@
         </p:nvSpPr>
         <p:spPr>
           <a:xfrm>
-            <a:off x="1143000" y="5029200"/>
-            <a:ext cx="4297680" cy="1051560"/>
+            <a:off x="1143000" y="4864608"/>
+            <a:ext cx="4297680" cy="822960"/>
           </a:xfrm>
           <a:prstGeom prst="rect">
             <a:avLst/>
@@ -7664,7 +7401,7 @@
           <a:p>
             <a:pPr indent="0" marL="0">
               <a:lnSpc>
-                <a:spcPts val="1700"/>
+                <a:spcPts val="1800"/>
               </a:lnSpc>
               <a:buNone/>
             </a:pPr>
@@ -7682,12 +7419,12 @@
             </a:r>
             <a:pPr indent="0" marL="0">
               <a:lnSpc>
-                <a:spcPts val="1700"/>
+                <a:spcPts val="1800"/>
               </a:lnSpc>
               <a:buNone/>
             </a:pPr>
             <a:r>
-              <a:rPr lang="en-US" sz="1300" dirty="0">
+              <a:rPr lang="en-US" sz="1350" dirty="0">
                 <a:solidFill>
                   <a:srgbClr val="1C2E22"/>
                 </a:solidFill>
@@ -7695,7 +7432,7 @@
                 <a:ea typeface="Calibri" pitchFamily="34" charset="-122"/>
                 <a:cs typeface="Calibri" pitchFamily="34" charset="-120"/>
               </a:rPr>
-              <a:t>Reports are slow and error-prone; co-purchase relationships are invisible in current tools.</a:t>
+              <a:t>Slow, manual reports; co-purchase patterns are invisible.</a:t>
             </a:r>
             <a:endParaRPr lang="en-US" sz="1100" dirty="0"/>
           </a:p>
@@ -7710,11 +7447,11 @@
         <p:spPr>
           <a:xfrm>
             <a:off x="6355080" y="1783080"/>
-            <a:ext cx="5029200" cy="4434840"/>
+            <a:ext cx="5029200" cy="4206240"/>
           </a:xfrm>
           <a:prstGeom prst="roundRect">
             <a:avLst>
-              <a:gd name="adj" fmla="val 1443"/>
+              <a:gd name="adj" fmla="val 1522"/>
             </a:avLst>
           </a:prstGeom>
           <a:solidFill>
@@ -7865,8 +7602,8 @@
         </p:nvSpPr>
         <p:spPr>
           <a:xfrm>
-            <a:off x="6720840" y="3291840"/>
-            <a:ext cx="4297680" cy="640080"/>
+            <a:off x="6720840" y="3310128"/>
+            <a:ext cx="4297680" cy="457200"/>
           </a:xfrm>
           <a:prstGeom prst="rect">
             <a:avLst/>
@@ -7893,7 +7630,7 @@
                 <a:ea typeface="Calibri" pitchFamily="34" charset="-122"/>
                 <a:cs typeface="Calibri" pitchFamily="34" charset="-120"/>
               </a:rPr>
-              <a:t>28 · Retail Management · 2 years in e-commerce grocery · comfortable with KPIs, no coding</a:t>
+              <a:t>28 · Retail Management · 2 years in e-commerce grocery · no coding</a:t>
             </a:r>
             <a:endParaRPr lang="en-US" sz="1200" dirty="0"/>
           </a:p>
@@ -7907,8 +7644,8 @@
         </p:nvSpPr>
         <p:spPr>
           <a:xfrm>
-            <a:off x="6720840" y="4023360"/>
-            <a:ext cx="4297680" cy="1005840"/>
+            <a:off x="6720840" y="3950208"/>
+            <a:ext cx="4297680" cy="822960"/>
           </a:xfrm>
           <a:prstGeom prst="rect">
             <a:avLst/>
@@ -7922,7 +7659,7 @@
           <a:p>
             <a:pPr indent="0" marL="0">
               <a:lnSpc>
-                <a:spcPts val="1700"/>
+                <a:spcPts val="1800"/>
               </a:lnSpc>
               <a:buNone/>
             </a:pPr>
@@ -7940,12 +7677,12 @@
             </a:r>
             <a:pPr indent="0" marL="0">
               <a:lnSpc>
-                <a:spcPts val="1700"/>
+                <a:spcPts val="1800"/>
               </a:lnSpc>
               <a:buNone/>
             </a:pPr>
             <a:r>
-              <a:rPr lang="en-US" sz="1300" dirty="0">
+              <a:rPr lang="en-US" sz="1350" dirty="0">
                 <a:solidFill>
                   <a:srgbClr val="1C2E22"/>
                 </a:solidFill>
@@ -7953,7 +7690,7 @@
                 <a:ea typeface="Calibri" pitchFamily="34" charset="-122"/>
                 <a:cs typeface="Calibri" pitchFamily="34" charset="-120"/>
               </a:rPr>
-              <a:t>Evidence for listing, delisting and supplier talks — and a way to spot loyal niche products.</a:t>
+              <a:t>Evidence for listing, delisting and supplier negotiations.</a:t>
             </a:r>
             <a:endParaRPr lang="en-US" sz="1100" dirty="0"/>
           </a:p>
@@ -7967,8 +7704,8 @@
         </p:nvSpPr>
         <p:spPr>
           <a:xfrm>
-            <a:off x="6720840" y="5029200"/>
-            <a:ext cx="4297680" cy="1051560"/>
+            <a:off x="6720840" y="4864608"/>
+            <a:ext cx="4297680" cy="822960"/>
           </a:xfrm>
           <a:prstGeom prst="rect">
             <a:avLst/>
@@ -7982,7 +7719,7 @@
           <a:p>
             <a:pPr indent="0" marL="0">
               <a:lnSpc>
-                <a:spcPts val="1700"/>
+                <a:spcPts val="1800"/>
               </a:lnSpc>
               <a:buNone/>
             </a:pPr>
@@ -8000,12 +7737,12 @@
             </a:r>
             <a:pPr indent="0" marL="0">
               <a:lnSpc>
-                <a:spcPts val="1700"/>
+                <a:spcPts val="1800"/>
               </a:lnSpc>
               <a:buNone/>
             </a:pPr>
             <a:r>
-              <a:rPr lang="en-US" sz="1300" dirty="0">
+              <a:rPr lang="en-US" sz="1350" dirty="0">
                 <a:solidFill>
                   <a:srgbClr val="1C2E22"/>
                 </a:solidFill>
@@ -8013,7 +7750,7 @@
                 <a:ea typeface="Calibri" pitchFamily="34" charset="-122"/>
                 <a:cs typeface="Calibri" pitchFamily="34" charset="-120"/>
               </a:rPr>
-              <a:t>Decisions lean on intuition; high-loyalty 'hidden gems' never show up in standard sales reports.</a:t>
+              <a:t>Decisions lean on gut feel; loyal niche products stay hidden.</a:t>
             </a:r>
             <a:endParaRPr lang="en-US" sz="1100" dirty="0"/>
           </a:p>
@@ -8215,8 +7952,8 @@
         </p:nvSpPr>
         <p:spPr>
           <a:xfrm>
-            <a:off x="777240" y="1645920"/>
-            <a:ext cx="8686800" cy="640080"/>
+            <a:off x="777240" y="1627632"/>
+            <a:ext cx="8686800" cy="457200"/>
           </a:xfrm>
           <a:prstGeom prst="rect">
             <a:avLst/>
@@ -8229,13 +7966,10 @@
           <a:lstStyle/>
           <a:p>
             <a:pPr indent="0" marL="0">
-              <a:lnSpc>
-                <a:spcPts val="2100"/>
-              </a:lnSpc>
-              <a:buNone/>
-            </a:pPr>
-            <a:r>
-              <a:rPr lang="en-US" sz="1500" dirty="0">
+              <a:buNone/>
+            </a:pPr>
+            <a:r>
+              <a:rPr lang="en-US" sz="1600" dirty="0">
                 <a:solidFill>
                   <a:srgbClr val="A9C9A0"/>
                 </a:solidFill>
@@ -8243,9 +7977,9 @@
                 <a:ea typeface="Calibri" pitchFamily="34" charset="-122"/>
                 <a:cs typeface="Calibri" pitchFamily="34" charset="-120"/>
               </a:rPr>
-              <a:t>Built for exploration, not static reporting. Three sections mirror the way planners and buyers actually think about the business.</a:t>
-            </a:r>
-            <a:endParaRPr lang="en-US" sz="1500" dirty="0"/>
+              <a:t>Built for exploration, not static reporting.</a:t>
+            </a:r>
+            <a:endParaRPr lang="en-US" sz="1600" dirty="0"/>
           </a:p>
         </p:txBody>
       </p:sp>
@@ -8257,12 +7991,12 @@
         </p:nvSpPr>
         <p:spPr>
           <a:xfrm>
-            <a:off x="777240" y="2514600"/>
-            <a:ext cx="3456432" cy="3429000"/>
+            <a:off x="777240" y="2377440"/>
+            <a:ext cx="3456432" cy="3520440"/>
           </a:xfrm>
           <a:prstGeom prst="roundRect">
             <a:avLst>
-              <a:gd name="adj" fmla="val 1867"/>
+              <a:gd name="adj" fmla="val 1852"/>
             </a:avLst>
           </a:prstGeom>
           <a:solidFill>
@@ -8284,7 +8018,7 @@
         </p:nvSpPr>
         <p:spPr>
           <a:xfrm>
-            <a:off x="1097280" y="2743200"/>
+            <a:off x="1143000" y="2670048"/>
             <a:ext cx="1097280" cy="548640"/>
           </a:xfrm>
           <a:prstGeom prst="rect">
@@ -8323,8 +8057,8 @@
         </p:nvSpPr>
         <p:spPr>
           <a:xfrm>
-            <a:off x="1097280" y="3310128"/>
-            <a:ext cx="2834640" cy="640080"/>
+            <a:off x="1143000" y="3236976"/>
+            <a:ext cx="2743200" cy="868680"/>
           </a:xfrm>
           <a:prstGeom prst="rect">
             <a:avLst/>
@@ -8338,12 +8072,12 @@
           <a:p>
             <a:pPr indent="0" marL="0">
               <a:lnSpc>
-                <a:spcPts val="2200"/>
+                <a:spcPts val="2300"/>
               </a:lnSpc>
               <a:buNone/>
             </a:pPr>
             <a:r>
-              <a:rPr lang="en-US" sz="1900" b="1" dirty="0">
+              <a:rPr lang="en-US" sz="2000" b="1" dirty="0">
                 <a:solidFill>
                   <a:srgbClr val="FFFFFF"/>
                 </a:solidFill>
@@ -8353,7 +8087,7 @@
               </a:rPr>
               <a:t>KPI Overview</a:t>
             </a:r>
-            <a:endParaRPr lang="en-US" sz="1900" dirty="0"/>
+            <a:endParaRPr lang="en-US" sz="2000" dirty="0"/>
           </a:p>
         </p:txBody>
       </p:sp>
@@ -8365,27 +8099,31 @@
         </p:nvSpPr>
         <p:spPr>
           <a:xfrm>
-            <a:off x="1097280" y="3931920"/>
-            <a:ext cx="2834640" cy="685800"/>
-          </a:xfrm>
-          <a:prstGeom prst="rect">
-            <a:avLst/>
-          </a:prstGeom>
-          <a:noFill/>
-          <a:ln/>
-        </p:spPr>
-        <p:txBody>
-          <a:bodyPr wrap="square" lIns="0" tIns="0" rIns="0" bIns="0" rtlCol="0" anchor="t"/>
-          <a:lstStyle/>
-          <a:p>
-            <a:pPr indent="0" marL="0">
+            <a:off x="1170432" y="4297680"/>
+            <a:ext cx="2788920" cy="1371600"/>
+          </a:xfrm>
+          <a:prstGeom prst="rect">
+            <a:avLst/>
+          </a:prstGeom>
+          <a:noFill/>
+          <a:ln/>
+        </p:spPr>
+        <p:txBody>
+          <a:bodyPr wrap="square" lIns="0" tIns="0" rIns="0" bIns="0" rtlCol="0" anchor="ctr"/>
+          <a:lstStyle/>
+          <a:p>
+            <a:pPr marL="342900" indent="-342900">
               <a:lnSpc>
-                <a:spcPts val="1600"/>
+                <a:spcPts val="1500"/>
               </a:lnSpc>
-              <a:buNone/>
-            </a:pPr>
-            <a:r>
-              <a:rPr lang="en-US" sz="1200" dirty="0">
+              <a:spcAft>
+                <a:spcPts val="700"/>
+              </a:spcAft>
+              <a:buSzPct val="100000"/>
+              <a:buChar char="•"/>
+            </a:pPr>
+            <a:r>
+              <a:rPr lang="en-US" sz="1250" dirty="0">
                 <a:solidFill>
                   <a:srgbClr val="A9C9A0"/>
                 </a:solidFill>
@@ -8393,120 +8131,74 @@
                 <a:ea typeface="Calibri" pitchFamily="34" charset="-122"/>
                 <a:cs typeface="Calibri" pitchFamily="34" charset="-120"/>
               </a:rPr>
-              <a:t>The landing page — six headline metrics for instant orientation.</a:t>
-            </a:r>
-            <a:endParaRPr lang="en-US" sz="1200" dirty="0"/>
-          </a:p>
-        </p:txBody>
-      </p:sp>
-      <p:sp>
-        <p:nvSpPr>
-          <p:cNvPr id="9" name="Text 7"/>
-          <p:cNvSpPr/>
-          <p:nvPr/>
-        </p:nvSpPr>
-        <p:spPr>
-          <a:xfrm>
-            <a:off x="1124712" y="4681728"/>
-            <a:ext cx="2788920" cy="1097280"/>
-          </a:xfrm>
-          <a:prstGeom prst="rect">
-            <a:avLst/>
-          </a:prstGeom>
-          <a:noFill/>
-          <a:ln/>
-        </p:spPr>
-        <p:txBody>
-          <a:bodyPr wrap="square" lIns="0" tIns="0" rIns="0" bIns="0" rtlCol="0" anchor="ctr"/>
-          <a:lstStyle/>
+              <a:t>Orders, customers, products</a:t>
+            </a:r>
+            <a:endParaRPr lang="en-US" sz="1250" dirty="0"/>
+          </a:p>
           <a:p>
             <a:pPr marL="342900" indent="-342900">
               <a:lnSpc>
-                <a:spcPts val="1400"/>
+                <a:spcPts val="1500"/>
               </a:lnSpc>
               <a:spcAft>
-                <a:spcPts val="400"/>
+                <a:spcPts val="700"/>
               </a:spcAft>
               <a:buSzPct val="100000"/>
               <a:buChar char="•"/>
             </a:pPr>
             <a:r>
-              <a:rPr lang="en-US" sz="1150" dirty="0">
-                <a:solidFill>
-                  <a:srgbClr val="FFFFFF"/>
+              <a:rPr lang="en-US" sz="1250" dirty="0">
+                <a:solidFill>
+                  <a:srgbClr val="A9C9A0"/>
                 </a:solidFill>
                 <a:latin typeface="Calibri" pitchFamily="34" charset="0"/>
                 <a:ea typeface="Calibri" pitchFamily="34" charset="-122"/>
                 <a:cs typeface="Calibri" pitchFamily="34" charset="-120"/>
               </a:rPr>
-              <a:t>Orders, customers, products</a:t>
-            </a:r>
-            <a:endParaRPr lang="en-US" sz="1150" dirty="0"/>
+              <a:t>Reorder rate &amp; peak hour</a:t>
+            </a:r>
+            <a:endParaRPr lang="en-US" sz="1250" dirty="0"/>
           </a:p>
           <a:p>
             <a:pPr marL="342900" indent="-342900">
               <a:lnSpc>
-                <a:spcPts val="1400"/>
+                <a:spcPts val="1500"/>
               </a:lnSpc>
               <a:spcAft>
-                <a:spcPts val="400"/>
+                <a:spcPts val="700"/>
               </a:spcAft>
               <a:buSzPct val="100000"/>
               <a:buChar char="•"/>
             </a:pPr>
             <a:r>
-              <a:rPr lang="en-US" sz="1150" dirty="0">
-                <a:solidFill>
-                  <a:srgbClr val="FFFFFF"/>
+              <a:rPr lang="en-US" sz="1250" dirty="0">
+                <a:solidFill>
+                  <a:srgbClr val="A9C9A0"/>
                 </a:solidFill>
                 <a:latin typeface="Calibri" pitchFamily="34" charset="0"/>
                 <a:ea typeface="Calibri" pitchFamily="34" charset="-122"/>
                 <a:cs typeface="Calibri" pitchFamily="34" charset="-120"/>
               </a:rPr>
-              <a:t>Reorder rate &amp; peak hour</a:t>
-            </a:r>
-            <a:endParaRPr lang="en-US" sz="1150" dirty="0"/>
-          </a:p>
-          <a:p>
-            <a:pPr marL="342900" indent="-342900">
-              <a:lnSpc>
-                <a:spcPts val="1400"/>
-              </a:lnSpc>
-              <a:spcAft>
-                <a:spcPts val="400"/>
-              </a:spcAft>
-              <a:buSzPct val="100000"/>
-              <a:buChar char="•"/>
-            </a:pPr>
-            <a:r>
-              <a:rPr lang="en-US" sz="1150" dirty="0">
-                <a:solidFill>
-                  <a:srgbClr val="FFFFFF"/>
-                </a:solidFill>
-                <a:latin typeface="Calibri" pitchFamily="34" charset="0"/>
-                <a:ea typeface="Calibri" pitchFamily="34" charset="-122"/>
-                <a:cs typeface="Calibri" pitchFamily="34" charset="-120"/>
-              </a:rPr>
               <a:t>Top department</a:t>
             </a:r>
-            <a:endParaRPr lang="en-US" sz="1150" dirty="0"/>
-          </a:p>
-        </p:txBody>
-      </p:sp>
-      <p:sp>
-        <p:nvSpPr>
-          <p:cNvPr id="10" name="Shape 8"/>
-          <p:cNvSpPr/>
-          <p:nvPr/>
-        </p:nvSpPr>
-        <p:spPr>
-          <a:xfrm>
-            <a:off x="4407408" y="2514600"/>
-            <a:ext cx="3456432" cy="3429000"/>
+            <a:endParaRPr lang="en-US" sz="1250" dirty="0"/>
+          </a:p>
+        </p:txBody>
+      </p:sp>
+      <p:sp>
+        <p:nvSpPr>
+          <p:cNvPr id="9" name="Shape 7"/>
+          <p:cNvSpPr/>
+          <p:nvPr/>
+        </p:nvSpPr>
+        <p:spPr>
+          <a:xfrm>
+            <a:off x="4407408" y="2377440"/>
+            <a:ext cx="3456432" cy="3520440"/>
           </a:xfrm>
           <a:prstGeom prst="roundRect">
             <a:avLst>
-              <a:gd name="adj" fmla="val 1867"/>
+              <a:gd name="adj" fmla="val 1852"/>
             </a:avLst>
           </a:prstGeom>
           <a:solidFill>
@@ -8522,13 +8214,13 @@
       </p:sp>
       <p:sp>
         <p:nvSpPr>
-          <p:cNvPr id="11" name="Text 9"/>
-          <p:cNvSpPr/>
-          <p:nvPr/>
-        </p:nvSpPr>
-        <p:spPr>
-          <a:xfrm>
-            <a:off x="4727448" y="2743200"/>
+          <p:cNvPr id="10" name="Text 8"/>
+          <p:cNvSpPr/>
+          <p:nvPr/>
+        </p:nvSpPr>
+        <p:spPr>
+          <a:xfrm>
+            <a:off x="4773168" y="2670048"/>
             <a:ext cx="1097280" cy="548640"/>
           </a:xfrm>
           <a:prstGeom prst="rect">
@@ -8561,14 +8253,14 @@
       </p:sp>
       <p:sp>
         <p:nvSpPr>
-          <p:cNvPr id="12" name="Text 10"/>
-          <p:cNvSpPr/>
-          <p:nvPr/>
-        </p:nvSpPr>
-        <p:spPr>
-          <a:xfrm>
-            <a:off x="4727448" y="3310128"/>
-            <a:ext cx="2834640" cy="640080"/>
+          <p:cNvPr id="11" name="Text 9"/>
+          <p:cNvSpPr/>
+          <p:nvPr/>
+        </p:nvSpPr>
+        <p:spPr>
+          <a:xfrm>
+            <a:off x="4773168" y="3236976"/>
+            <a:ext cx="2743200" cy="868680"/>
           </a:xfrm>
           <a:prstGeom prst="rect">
             <a:avLst/>
@@ -8582,12 +8274,12 @@
           <a:p>
             <a:pPr indent="0" marL="0">
               <a:lnSpc>
-                <a:spcPts val="2200"/>
+                <a:spcPts val="2300"/>
               </a:lnSpc>
               <a:buNone/>
             </a:pPr>
             <a:r>
-              <a:rPr lang="en-US" sz="1900" b="1" dirty="0">
+              <a:rPr lang="en-US" sz="2000" b="1" dirty="0">
                 <a:solidFill>
                   <a:srgbClr val="FFFFFF"/>
                 </a:solidFill>
@@ -8597,39 +8289,43 @@
               </a:rPr>
               <a:t>Product Development</a:t>
             </a:r>
-            <a:endParaRPr lang="en-US" sz="1900" dirty="0"/>
-          </a:p>
-        </p:txBody>
-      </p:sp>
-      <p:sp>
-        <p:nvSpPr>
-          <p:cNvPr id="13" name="Text 11"/>
-          <p:cNvSpPr/>
-          <p:nvPr/>
-        </p:nvSpPr>
-        <p:spPr>
-          <a:xfrm>
-            <a:off x="4727448" y="3931920"/>
-            <a:ext cx="2834640" cy="685800"/>
-          </a:xfrm>
-          <a:prstGeom prst="rect">
-            <a:avLst/>
-          </a:prstGeom>
-          <a:noFill/>
-          <a:ln/>
-        </p:spPr>
-        <p:txBody>
-          <a:bodyPr wrap="square" lIns="0" tIns="0" rIns="0" bIns="0" rtlCol="0" anchor="t"/>
-          <a:lstStyle/>
-          <a:p>
-            <a:pPr indent="0" marL="0">
+            <a:endParaRPr lang="en-US" sz="2000" dirty="0"/>
+          </a:p>
+        </p:txBody>
+      </p:sp>
+      <p:sp>
+        <p:nvSpPr>
+          <p:cNvPr id="12" name="Text 10"/>
+          <p:cNvSpPr/>
+          <p:nvPr/>
+        </p:nvSpPr>
+        <p:spPr>
+          <a:xfrm>
+            <a:off x="4800600" y="4297680"/>
+            <a:ext cx="2788920" cy="1371600"/>
+          </a:xfrm>
+          <a:prstGeom prst="rect">
+            <a:avLst/>
+          </a:prstGeom>
+          <a:noFill/>
+          <a:ln/>
+        </p:spPr>
+        <p:txBody>
+          <a:bodyPr wrap="square" lIns="0" tIns="0" rIns="0" bIns="0" rtlCol="0" anchor="ctr"/>
+          <a:lstStyle/>
+          <a:p>
+            <a:pPr marL="342900" indent="-342900">
               <a:lnSpc>
-                <a:spcPts val="1600"/>
+                <a:spcPts val="1500"/>
               </a:lnSpc>
-              <a:buNone/>
-            </a:pPr>
-            <a:r>
-              <a:rPr lang="en-US" sz="1200" dirty="0">
+              <a:spcAft>
+                <a:spcPts val="700"/>
+              </a:spcAft>
+              <a:buSzPct val="100000"/>
+              <a:buChar char="•"/>
+            </a:pPr>
+            <a:r>
+              <a:rPr lang="en-US" sz="1250" dirty="0">
                 <a:solidFill>
                   <a:srgbClr val="A9C9A0"/>
                 </a:solidFill>
@@ -8637,120 +8333,74 @@
                 <a:ea typeface="Calibri" pitchFamily="34" charset="-122"/>
                 <a:cs typeface="Calibri" pitchFamily="34" charset="-120"/>
               </a:rPr>
-              <a:t>What sells, and what sells together.</a:t>
-            </a:r>
-            <a:endParaRPr lang="en-US" sz="1200" dirty="0"/>
-          </a:p>
-        </p:txBody>
-      </p:sp>
-      <p:sp>
-        <p:nvSpPr>
-          <p:cNvPr id="14" name="Text 12"/>
-          <p:cNvSpPr/>
-          <p:nvPr/>
-        </p:nvSpPr>
-        <p:spPr>
-          <a:xfrm>
-            <a:off x="4754880" y="4681728"/>
-            <a:ext cx="2788920" cy="1097280"/>
-          </a:xfrm>
-          <a:prstGeom prst="rect">
-            <a:avLst/>
-          </a:prstGeom>
-          <a:noFill/>
-          <a:ln/>
-        </p:spPr>
-        <p:txBody>
-          <a:bodyPr wrap="square" lIns="0" tIns="0" rIns="0" bIns="0" rtlCol="0" anchor="ctr"/>
-          <a:lstStyle/>
+              <a:t>Top sellers</a:t>
+            </a:r>
+            <a:endParaRPr lang="en-US" sz="1250" dirty="0"/>
+          </a:p>
           <a:p>
             <a:pPr marL="342900" indent="-342900">
               <a:lnSpc>
-                <a:spcPts val="1400"/>
+                <a:spcPts val="1500"/>
               </a:lnSpc>
               <a:spcAft>
-                <a:spcPts val="400"/>
+                <a:spcPts val="700"/>
               </a:spcAft>
               <a:buSzPct val="100000"/>
               <a:buChar char="•"/>
             </a:pPr>
             <a:r>
-              <a:rPr lang="en-US" sz="1150" dirty="0">
-                <a:solidFill>
-                  <a:srgbClr val="FFFFFF"/>
+              <a:rPr lang="en-US" sz="1250" dirty="0">
+                <a:solidFill>
+                  <a:srgbClr val="A9C9A0"/>
                 </a:solidFill>
                 <a:latin typeface="Calibri" pitchFamily="34" charset="0"/>
                 <a:ea typeface="Calibri" pitchFamily="34" charset="-122"/>
                 <a:cs typeface="Calibri" pitchFamily="34" charset="-120"/>
               </a:rPr>
-              <a:t>Top sellers</a:t>
-            </a:r>
-            <a:endParaRPr lang="en-US" sz="1150" dirty="0"/>
+              <a:t>Department sales</a:t>
+            </a:r>
+            <a:endParaRPr lang="en-US" sz="1250" dirty="0"/>
           </a:p>
           <a:p>
             <a:pPr marL="342900" indent="-342900">
               <a:lnSpc>
-                <a:spcPts val="1400"/>
+                <a:spcPts val="1500"/>
               </a:lnSpc>
               <a:spcAft>
-                <a:spcPts val="400"/>
+                <a:spcPts val="700"/>
               </a:spcAft>
               <a:buSzPct val="100000"/>
               <a:buChar char="•"/>
             </a:pPr>
             <a:r>
-              <a:rPr lang="en-US" sz="1150" dirty="0">
-                <a:solidFill>
-                  <a:srgbClr val="FFFFFF"/>
+              <a:rPr lang="en-US" sz="1250" dirty="0">
+                <a:solidFill>
+                  <a:srgbClr val="A9C9A0"/>
                 </a:solidFill>
                 <a:latin typeface="Calibri" pitchFamily="34" charset="0"/>
                 <a:ea typeface="Calibri" pitchFamily="34" charset="-122"/>
                 <a:cs typeface="Calibri" pitchFamily="34" charset="-120"/>
               </a:rPr>
-              <a:t>Department sales</a:t>
-            </a:r>
-            <a:endParaRPr lang="en-US" sz="1150" dirty="0"/>
-          </a:p>
-          <a:p>
-            <a:pPr marL="342900" indent="-342900">
-              <a:lnSpc>
-                <a:spcPts val="1400"/>
-              </a:lnSpc>
-              <a:spcAft>
-                <a:spcPts val="400"/>
-              </a:spcAft>
-              <a:buSzPct val="100000"/>
-              <a:buChar char="•"/>
-            </a:pPr>
-            <a:r>
-              <a:rPr lang="en-US" sz="1150" dirty="0">
-                <a:solidFill>
-                  <a:srgbClr val="FFFFFF"/>
-                </a:solidFill>
-                <a:latin typeface="Calibri" pitchFamily="34" charset="0"/>
-                <a:ea typeface="Calibri" pitchFamily="34" charset="-122"/>
-                <a:cs typeface="Calibri" pitchFamily="34" charset="-120"/>
-              </a:rPr>
               <a:t>Products bought together</a:t>
             </a:r>
-            <a:endParaRPr lang="en-US" sz="1150" dirty="0"/>
-          </a:p>
-        </p:txBody>
-      </p:sp>
-      <p:sp>
-        <p:nvSpPr>
-          <p:cNvPr id="15" name="Shape 13"/>
-          <p:cNvSpPr/>
-          <p:nvPr/>
-        </p:nvSpPr>
-        <p:spPr>
-          <a:xfrm>
-            <a:off x="8037576" y="2514600"/>
-            <a:ext cx="3456432" cy="3429000"/>
+            <a:endParaRPr lang="en-US" sz="1250" dirty="0"/>
+          </a:p>
+        </p:txBody>
+      </p:sp>
+      <p:sp>
+        <p:nvSpPr>
+          <p:cNvPr id="13" name="Shape 11"/>
+          <p:cNvSpPr/>
+          <p:nvPr/>
+        </p:nvSpPr>
+        <p:spPr>
+          <a:xfrm>
+            <a:off x="8037576" y="2377440"/>
+            <a:ext cx="3456432" cy="3520440"/>
           </a:xfrm>
           <a:prstGeom prst="roundRect">
             <a:avLst>
-              <a:gd name="adj" fmla="val 1867"/>
+              <a:gd name="adj" fmla="val 1852"/>
             </a:avLst>
           </a:prstGeom>
           <a:solidFill>
@@ -8766,13 +8416,13 @@
       </p:sp>
       <p:sp>
         <p:nvSpPr>
-          <p:cNvPr id="16" name="Text 14"/>
-          <p:cNvSpPr/>
-          <p:nvPr/>
-        </p:nvSpPr>
-        <p:spPr>
-          <a:xfrm>
-            <a:off x="8357616" y="2743200"/>
+          <p:cNvPr id="14" name="Text 12"/>
+          <p:cNvSpPr/>
+          <p:nvPr/>
+        </p:nvSpPr>
+        <p:spPr>
+          <a:xfrm>
+            <a:off x="8403336" y="2670048"/>
             <a:ext cx="1097280" cy="548640"/>
           </a:xfrm>
           <a:prstGeom prst="rect">
@@ -8805,14 +8455,14 @@
       </p:sp>
       <p:sp>
         <p:nvSpPr>
-          <p:cNvPr id="17" name="Text 15"/>
-          <p:cNvSpPr/>
-          <p:nvPr/>
-        </p:nvSpPr>
-        <p:spPr>
-          <a:xfrm>
-            <a:off x="8357616" y="3310128"/>
-            <a:ext cx="2834640" cy="640080"/>
+          <p:cNvPr id="15" name="Text 13"/>
+          <p:cNvSpPr/>
+          <p:nvPr/>
+        </p:nvSpPr>
+        <p:spPr>
+          <a:xfrm>
+            <a:off x="8403336" y="3236976"/>
+            <a:ext cx="2743200" cy="868680"/>
           </a:xfrm>
           <a:prstGeom prst="rect">
             <a:avLst/>
@@ -8826,12 +8476,12 @@
           <a:p>
             <a:pPr indent="0" marL="0">
               <a:lnSpc>
-                <a:spcPts val="2200"/>
+                <a:spcPts val="2300"/>
               </a:lnSpc>
               <a:buNone/>
             </a:pPr>
             <a:r>
-              <a:rPr lang="en-US" sz="1900" b="1" dirty="0">
+              <a:rPr lang="en-US" sz="2000" b="1" dirty="0">
                 <a:solidFill>
                   <a:srgbClr val="FFFFFF"/>
                 </a:solidFill>
@@ -8841,39 +8491,43 @@
               </a:rPr>
               <a:t>Customer Retention</a:t>
             </a:r>
-            <a:endParaRPr lang="en-US" sz="1900" dirty="0"/>
-          </a:p>
-        </p:txBody>
-      </p:sp>
-      <p:sp>
-        <p:nvSpPr>
-          <p:cNvPr id="18" name="Text 16"/>
-          <p:cNvSpPr/>
-          <p:nvPr/>
-        </p:nvSpPr>
-        <p:spPr>
-          <a:xfrm>
-            <a:off x="8357616" y="3931920"/>
-            <a:ext cx="2834640" cy="685800"/>
-          </a:xfrm>
-          <a:prstGeom prst="rect">
-            <a:avLst/>
-          </a:prstGeom>
-          <a:noFill/>
-          <a:ln/>
-        </p:spPr>
-        <p:txBody>
-          <a:bodyPr wrap="square" lIns="0" tIns="0" rIns="0" bIns="0" rtlCol="0" anchor="t"/>
-          <a:lstStyle/>
-          <a:p>
-            <a:pPr indent="0" marL="0">
+            <a:endParaRPr lang="en-US" sz="2000" dirty="0"/>
+          </a:p>
+        </p:txBody>
+      </p:sp>
+      <p:sp>
+        <p:nvSpPr>
+          <p:cNvPr id="16" name="Text 14"/>
+          <p:cNvSpPr/>
+          <p:nvPr/>
+        </p:nvSpPr>
+        <p:spPr>
+          <a:xfrm>
+            <a:off x="8430768" y="4297680"/>
+            <a:ext cx="2788920" cy="1371600"/>
+          </a:xfrm>
+          <a:prstGeom prst="rect">
+            <a:avLst/>
+          </a:prstGeom>
+          <a:noFill/>
+          <a:ln/>
+        </p:spPr>
+        <p:txBody>
+          <a:bodyPr wrap="square" lIns="0" tIns="0" rIns="0" bIns="0" rtlCol="0" anchor="ctr"/>
+          <a:lstStyle/>
+          <a:p>
+            <a:pPr marL="342900" indent="-342900">
               <a:lnSpc>
-                <a:spcPts val="1600"/>
+                <a:spcPts val="1500"/>
               </a:lnSpc>
-              <a:buNone/>
-            </a:pPr>
-            <a:r>
-              <a:rPr lang="en-US" sz="1200" dirty="0">
+              <a:spcAft>
+                <a:spcPts val="700"/>
+              </a:spcAft>
+              <a:buSzPct val="100000"/>
+              <a:buChar char="•"/>
+            </a:pPr>
+            <a:r>
+              <a:rPr lang="en-US" sz="1250" dirty="0">
                 <a:solidFill>
                   <a:srgbClr val="A9C9A0"/>
                 </a:solidFill>
@@ -8881,116 +8535,109 @@
                 <a:ea typeface="Calibri" pitchFamily="34" charset="-122"/>
                 <a:cs typeface="Calibri" pitchFamily="34" charset="-120"/>
               </a:rPr>
-              <a:t>Who comes back, and when.</a:t>
-            </a:r>
-            <a:endParaRPr lang="en-US" sz="1200" dirty="0"/>
-          </a:p>
-        </p:txBody>
-      </p:sp>
-      <p:sp>
-        <p:nvSpPr>
-          <p:cNvPr id="19" name="Text 17"/>
-          <p:cNvSpPr/>
-          <p:nvPr/>
-        </p:nvSpPr>
-        <p:spPr>
-          <a:xfrm>
-            <a:off x="8385048" y="4681728"/>
-            <a:ext cx="2788920" cy="1097280"/>
-          </a:xfrm>
-          <a:prstGeom prst="rect">
-            <a:avLst/>
-          </a:prstGeom>
-          <a:noFill/>
-          <a:ln/>
-        </p:spPr>
-        <p:txBody>
-          <a:bodyPr wrap="square" lIns="0" tIns="0" rIns="0" bIns="0" rtlCol="0" anchor="ctr"/>
-          <a:lstStyle/>
+              <a:t>Reorder rate</a:t>
+            </a:r>
+            <a:endParaRPr lang="en-US" sz="1250" dirty="0"/>
+          </a:p>
           <a:p>
             <a:pPr marL="342900" indent="-342900">
               <a:lnSpc>
-                <a:spcPts val="1400"/>
+                <a:spcPts val="1500"/>
               </a:lnSpc>
               <a:spcAft>
-                <a:spcPts val="400"/>
+                <a:spcPts val="700"/>
               </a:spcAft>
               <a:buSzPct val="100000"/>
               <a:buChar char="•"/>
             </a:pPr>
             <a:r>
-              <a:rPr lang="en-US" sz="1150" dirty="0">
-                <a:solidFill>
-                  <a:srgbClr val="FFFFFF"/>
+              <a:rPr lang="en-US" sz="1250" dirty="0">
+                <a:solidFill>
+                  <a:srgbClr val="A9C9A0"/>
                 </a:solidFill>
                 <a:latin typeface="Calibri" pitchFamily="34" charset="0"/>
                 <a:ea typeface="Calibri" pitchFamily="34" charset="-122"/>
                 <a:cs typeface="Calibri" pitchFamily="34" charset="-120"/>
               </a:rPr>
-              <a:t>Reorder rate</a:t>
-            </a:r>
-            <a:endParaRPr lang="en-US" sz="1150" dirty="0"/>
+              <a:t>Hidden gems</a:t>
+            </a:r>
+            <a:endParaRPr lang="en-US" sz="1250" dirty="0"/>
           </a:p>
           <a:p>
             <a:pPr marL="342900" indent="-342900">
               <a:lnSpc>
-                <a:spcPts val="1400"/>
+                <a:spcPts val="1500"/>
               </a:lnSpc>
               <a:spcAft>
-                <a:spcPts val="400"/>
+                <a:spcPts val="700"/>
               </a:spcAft>
               <a:buSzPct val="100000"/>
               <a:buChar char="•"/>
             </a:pPr>
             <a:r>
-              <a:rPr lang="en-US" sz="1150" dirty="0">
-                <a:solidFill>
-                  <a:srgbClr val="FFFFFF"/>
+              <a:rPr lang="en-US" sz="1250" dirty="0">
+                <a:solidFill>
+                  <a:srgbClr val="A9C9A0"/>
                 </a:solidFill>
                 <a:latin typeface="Calibri" pitchFamily="34" charset="0"/>
                 <a:ea typeface="Calibri" pitchFamily="34" charset="-122"/>
                 <a:cs typeface="Calibri" pitchFamily="34" charset="-120"/>
               </a:rPr>
-              <a:t>Hidden gems</a:t>
-            </a:r>
-            <a:endParaRPr lang="en-US" sz="1150" dirty="0"/>
-          </a:p>
-          <a:p>
-            <a:pPr marL="342900" indent="-342900">
-              <a:lnSpc>
-                <a:spcPts val="1400"/>
-              </a:lnSpc>
-              <a:spcAft>
-                <a:spcPts val="400"/>
-              </a:spcAft>
-              <a:buSzPct val="100000"/>
-              <a:buChar char="•"/>
-            </a:pPr>
-            <a:r>
-              <a:rPr lang="en-US" sz="1150" dirty="0">
-                <a:solidFill>
-                  <a:srgbClr val="FFFFFF"/>
+              <a:t>Shopping-time heatmap</a:t>
+            </a:r>
+            <a:endParaRPr lang="en-US" sz="1250" dirty="0"/>
+          </a:p>
+        </p:txBody>
+      </p:sp>
+      <p:sp>
+        <p:nvSpPr>
+          <p:cNvPr id="17" name="Text 15"/>
+          <p:cNvSpPr/>
+          <p:nvPr/>
+        </p:nvSpPr>
+        <p:spPr>
+          <a:xfrm>
+            <a:off x="777240" y="6126480"/>
+            <a:ext cx="8229600" cy="320040"/>
+          </a:xfrm>
+          <a:prstGeom prst="rect">
+            <a:avLst/>
+          </a:prstGeom>
+          <a:noFill/>
+          <a:ln/>
+        </p:spPr>
+        <p:txBody>
+          <a:bodyPr wrap="square" lIns="0" tIns="0" rIns="0" bIns="0" rtlCol="0" anchor="ctr"/>
+          <a:lstStyle/>
+          <a:p>
+            <a:pPr indent="0" marL="0">
+              <a:buNone/>
+            </a:pPr>
+            <a:r>
+              <a:rPr lang="en-US" sz="1200" i="1" dirty="0">
+                <a:solidFill>
+                  <a:srgbClr val="7BB274"/>
                 </a:solidFill>
                 <a:latin typeface="Calibri" pitchFamily="34" charset="0"/>
                 <a:ea typeface="Calibri" pitchFamily="34" charset="-122"/>
                 <a:cs typeface="Calibri" pitchFamily="34" charset="-120"/>
               </a:rPr>
-              <a:t>Shopping-time heatmap</a:t>
-            </a:r>
-            <a:endParaRPr lang="en-US" sz="1150" dirty="0"/>
-          </a:p>
-        </p:txBody>
-      </p:sp>
-      <p:sp>
-        <p:nvSpPr>
-          <p:cNvPr id="20" name="Text 18"/>
-          <p:cNvSpPr/>
-          <p:nvPr/>
-        </p:nvSpPr>
-        <p:spPr>
-          <a:xfrm>
-            <a:off x="777240" y="6172200"/>
-            <a:ext cx="8229600" cy="320040"/>
+              <a:t>Run it locally:  streamlit run deployment/app.py</a:t>
+            </a:r>
+            <a:endParaRPr lang="en-US" sz="1200" dirty="0"/>
+          </a:p>
+        </p:txBody>
+      </p:sp>
+      <p:sp>
+        <p:nvSpPr>
+          <p:cNvPr id="18" name="Text 16"/>
+          <p:cNvSpPr/>
+          <p:nvPr/>
+        </p:nvSpPr>
+        <p:spPr>
+          <a:xfrm>
+            <a:off x="777240" y="6455664"/>
+            <a:ext cx="7315200" cy="274320"/>
           </a:xfrm>
           <a:prstGeom prst="rect">
             <a:avLst/>
@@ -9002,57 +8649,18 @@
           <a:bodyPr wrap="square" lIns="0" tIns="0" rIns="0" bIns="0" rtlCol="0" anchor="ctr"/>
           <a:lstStyle/>
           <a:p>
-            <a:pPr indent="0" marL="0">
-              <a:buNone/>
-            </a:pPr>
-            <a:r>
-              <a:rPr lang="en-US" sz="1200" i="1" dirty="0">
-                <a:solidFill>
-                  <a:srgbClr val="7BB274"/>
+            <a:pPr algn="l" indent="0" marL="0">
+              <a:buNone/>
+            </a:pPr>
+            <a:r>
+              <a:rPr lang="en-US" sz="900" dirty="0">
+                <a:solidFill>
+                  <a:srgbClr val="9DB5A4"/>
                 </a:solidFill>
                 <a:latin typeface="Calibri" pitchFamily="34" charset="0"/>
                 <a:ea typeface="Calibri" pitchFamily="34" charset="-122"/>
                 <a:cs typeface="Calibri" pitchFamily="34" charset="-120"/>
               </a:rPr>
-              <a:t>Run it locally:  streamlit run deployment/app.py</a:t>
-            </a:r>
-            <a:endParaRPr lang="en-US" sz="1200" dirty="0"/>
-          </a:p>
-        </p:txBody>
-      </p:sp>
-      <p:sp>
-        <p:nvSpPr>
-          <p:cNvPr id="21" name="Text 19"/>
-          <p:cNvSpPr/>
-          <p:nvPr/>
-        </p:nvSpPr>
-        <p:spPr>
-          <a:xfrm>
-            <a:off x="777240" y="6455664"/>
-            <a:ext cx="7315200" cy="274320"/>
-          </a:xfrm>
-          <a:prstGeom prst="rect">
-            <a:avLst/>
-          </a:prstGeom>
-          <a:noFill/>
-          <a:ln/>
-        </p:spPr>
-        <p:txBody>
-          <a:bodyPr wrap="square" lIns="0" tIns="0" rIns="0" bIns="0" rtlCol="0" anchor="ctr"/>
-          <a:lstStyle/>
-          <a:p>
-            <a:pPr algn="l" indent="0" marL="0">
-              <a:buNone/>
-            </a:pPr>
-            <a:r>
-              <a:rPr lang="en-US" sz="900" dirty="0">
-                <a:solidFill>
-                  <a:srgbClr val="9DB5A4"/>
-                </a:solidFill>
-                <a:latin typeface="Calibri" pitchFamily="34" charset="0"/>
-                <a:ea typeface="Calibri" pitchFamily="34" charset="-122"/>
-                <a:cs typeface="Calibri" pitchFamily="34" charset="-120"/>
-              </a:rPr>
               <a:t>Grocery Product Placement Analysis  ·  Group 11</a:t>
             </a:r>
             <a:endParaRPr lang="en-US" sz="900" dirty="0"/>
@@ -9061,7 +8669,7 @@
       </p:sp>
       <p:sp>
         <p:nvSpPr>
-          <p:cNvPr id="22" name="Text 20"/>
+          <p:cNvPr id="19" name="Text 17"/>
           <p:cNvSpPr/>
           <p:nvPr/>
         </p:nvSpPr>
@@ -9240,30 +8848,16 @@
         </p:nvSpPr>
         <p:spPr>
           <a:xfrm>
-            <a:off x="8032090" y="1874520"/>
-            <a:ext cx="3382366" cy="2971800"/>
-          </a:xfrm>
-          <a:prstGeom prst="roundRect">
-            <a:avLst>
-              <a:gd name="adj" fmla="val 2462"/>
-            </a:avLst>
+            <a:off x="8123530" y="2217420"/>
+            <a:ext cx="64008" cy="3657600"/>
+          </a:xfrm>
+          <a:prstGeom prst="rect">
+            <a:avLst/>
           </a:prstGeom>
           <a:solidFill>
-            <a:srgbClr val="EEF2EC"/>
+            <a:srgbClr val="E07A3F"/>
           </a:solidFill>
-          <a:ln w="12700">
-            <a:solidFill>
-              <a:srgbClr val="D8E0D4"/>
-            </a:solidFill>
-            <a:prstDash val="solid"/>
-          </a:ln>
-          <a:effectLst>
-            <a:outerShdw sx="100000" sy="100000" kx="0" ky="0" algn="bl" rotWithShape="0" blurRad="114300" dist="38100" dir="8100000">
-              <a:srgbClr val="1C2E22">
-                <a:alpha val="16000"/>
-              </a:srgbClr>
-            </a:outerShdw>
-          </a:effectLst>
+          <a:ln/>
         </p:spPr>
       </p:sp>
       <p:sp>
@@ -9274,8 +8868,8 @@
         </p:nvSpPr>
         <p:spPr>
           <a:xfrm>
-            <a:off x="8324698" y="2121408"/>
-            <a:ext cx="2797150" cy="274320"/>
+            <a:off x="8416138" y="1988820"/>
+            <a:ext cx="2998318" cy="4114800"/>
           </a:xfrm>
           <a:prstGeom prst="rect">
             <a:avLst/>
@@ -9288,10 +8882,16 @@
           <a:lstStyle/>
           <a:p>
             <a:pPr indent="0" marL="0">
-              <a:buNone/>
-            </a:pPr>
-            <a:r>
-              <a:rPr lang="en-US" sz="1100" b="1" spc="200" kern="0" dirty="0">
+              <a:lnSpc>
+                <a:spcPts val="2600"/>
+              </a:lnSpc>
+              <a:spcAft>
+                <a:spcPts val="1000"/>
+              </a:spcAft>
+              <a:buNone/>
+            </a:pPr>
+            <a:r>
+              <a:rPr lang="en-US" sz="1150" b="1" spc="200" kern="0" dirty="0">
                 <a:solidFill>
                   <a:srgbClr val="2F6E4F"/>
                 </a:solidFill>
@@ -9299,44 +8899,20 @@
                 <a:ea typeface="Calibri" pitchFamily="34" charset="-122"/>
                 <a:cs typeface="Calibri" pitchFamily="34" charset="-120"/>
               </a:rPr>
-              <a:t>KEY FINDING</a:t>
-            </a:r>
-            <a:endParaRPr lang="en-US" sz="1100" dirty="0"/>
-          </a:p>
-        </p:txBody>
-      </p:sp>
-      <p:sp>
-        <p:nvSpPr>
-          <p:cNvPr id="7" name="Text 4"/>
-          <p:cNvSpPr/>
-          <p:nvPr/>
-        </p:nvSpPr>
-        <p:spPr>
-          <a:xfrm>
-            <a:off x="8324698" y="2432304"/>
-            <a:ext cx="2797150" cy="2286000"/>
-          </a:xfrm>
-          <a:prstGeom prst="rect">
-            <a:avLst/>
-          </a:prstGeom>
-          <a:noFill/>
-          <a:ln/>
-        </p:spPr>
-        <p:txBody>
-          <a:bodyPr wrap="square" lIns="0" tIns="0" rIns="0" bIns="0" rtlCol="0" anchor="t"/>
-          <a:lstStyle/>
-          <a:p>
+              <a:t>WHAT WE FOUND
+</a:t>
+            </a:r>
             <a:pPr indent="0" marL="0">
               <a:lnSpc>
-                <a:spcPts val="1800"/>
+                <a:spcPts val="2600"/>
               </a:lnSpc>
               <a:spcAft>
-                <a:spcPts val="800"/>
+                <a:spcPts val="1000"/>
               </a:spcAft>
               <a:buNone/>
             </a:pPr>
             <a:r>
-              <a:rPr lang="en-US" sz="1600" b="1" dirty="0">
+              <a:rPr lang="en-US" sz="2100" b="1" dirty="0">
                 <a:solidFill>
                   <a:srgbClr val="1C2E22"/>
                 </a:solidFill>
@@ -9344,145 +8920,45 @@
                 <a:ea typeface="Georgia" pitchFamily="34" charset="-122"/>
                 <a:cs typeface="Georgia" pitchFamily="34" charset="-120"/>
               </a:rPr>
-              <a:t>The entire top 15 is fresh fruit and vegetables.</a:t>
-            </a:r>
-            <a:endParaRPr lang="en-US" sz="1600" dirty="0"/>
-          </a:p>
-          <a:p>
-            <a:pPr indent="0" marL="0">
-              <a:lnSpc>
-                <a:spcPts val="1800"/>
-              </a:lnSpc>
-              <a:buNone/>
-            </a:pPr>
-            <a:r>
-              <a:rPr lang="en-US" sz="1250" dirty="0">
-                <a:solidFill>
-                  <a:srgbClr val="1C2E22"/>
+              <a:t>Every one of the top 15 products is fresh fruit or vegetables.</a:t>
+            </a:r>
+            <a:endParaRPr lang="en-US" sz="1150" dirty="0"/>
+          </a:p>
+        </p:txBody>
+      </p:sp>
+      <p:sp>
+        <p:nvSpPr>
+          <p:cNvPr id="8" name="Text 4"/>
+          <p:cNvSpPr/>
+          <p:nvPr/>
+        </p:nvSpPr>
+        <p:spPr>
+          <a:xfrm>
+            <a:off x="777240" y="6455664"/>
+            <a:ext cx="7315200" cy="274320"/>
+          </a:xfrm>
+          <a:prstGeom prst="rect">
+            <a:avLst/>
+          </a:prstGeom>
+          <a:noFill/>
+          <a:ln/>
+        </p:spPr>
+        <p:txBody>
+          <a:bodyPr wrap="square" lIns="0" tIns="0" rIns="0" bIns="0" rtlCol="0" anchor="ctr"/>
+          <a:lstStyle/>
+          <a:p>
+            <a:pPr algn="l" indent="0" marL="0">
+              <a:buNone/>
+            </a:pPr>
+            <a:r>
+              <a:rPr lang="en-US" sz="900" dirty="0">
+                <a:solidFill>
+                  <a:srgbClr val="6B7A6E"/>
                 </a:solidFill>
                 <a:latin typeface="Calibri" pitchFamily="34" charset="0"/>
                 <a:ea typeface="Calibri" pitchFamily="34" charset="-122"/>
                 <a:cs typeface="Calibri" pitchFamily="34" charset="-120"/>
               </a:rPr>
-              <a:t>Bananas lead at 0.47M purchases, followed by Bag of Organic Bananas and Organic Strawberries. More than half of the top sellers carry an “Organic” label.</a:t>
-            </a:r>
-            <a:endParaRPr lang="en-US" sz="1600" dirty="0"/>
-          </a:p>
-        </p:txBody>
-      </p:sp>
-      <p:sp>
-        <p:nvSpPr>
-          <p:cNvPr id="8" name="Shape 5"/>
-          <p:cNvSpPr/>
-          <p:nvPr/>
-        </p:nvSpPr>
-        <p:spPr>
-          <a:xfrm>
-            <a:off x="8032090" y="5074920"/>
-            <a:ext cx="64008" cy="1097280"/>
-          </a:xfrm>
-          <a:prstGeom prst="rect">
-            <a:avLst/>
-          </a:prstGeom>
-          <a:solidFill>
-            <a:srgbClr val="E07A3F"/>
-          </a:solidFill>
-          <a:ln/>
-        </p:spPr>
-      </p:sp>
-      <p:sp>
-        <p:nvSpPr>
-          <p:cNvPr id="9" name="Text 6"/>
-          <p:cNvSpPr/>
-          <p:nvPr/>
-        </p:nvSpPr>
-        <p:spPr>
-          <a:xfrm>
-            <a:off x="8278978" y="5074920"/>
-            <a:ext cx="3135478" cy="1097280"/>
-          </a:xfrm>
-          <a:prstGeom prst="rect">
-            <a:avLst/>
-          </a:prstGeom>
-          <a:noFill/>
-          <a:ln/>
-        </p:spPr>
-        <p:txBody>
-          <a:bodyPr wrap="square" lIns="0" tIns="0" rIns="0" bIns="0" rtlCol="0" anchor="t"/>
-          <a:lstStyle/>
-          <a:p>
-            <a:pPr indent="0" marL="0">
-              <a:lnSpc>
-                <a:spcPts val="1600"/>
-              </a:lnSpc>
-              <a:buNone/>
-            </a:pPr>
-            <a:r>
-              <a:rPr lang="en-US" sz="1050" b="1" spc="150" kern="0" dirty="0">
-                <a:solidFill>
-                  <a:srgbClr val="E07A3F"/>
-                </a:solidFill>
-                <a:latin typeface="Calibri" pitchFamily="34" charset="0"/>
-                <a:ea typeface="Calibri" pitchFamily="34" charset="-122"/>
-                <a:cs typeface="Calibri" pitchFamily="34" charset="-120"/>
-              </a:rPr>
-              <a:t>RECOMMENDATION
-</a:t>
-            </a:r>
-            <a:pPr indent="0" marL="0">
-              <a:lnSpc>
-                <a:spcPts val="1600"/>
-              </a:lnSpc>
-              <a:buNone/>
-            </a:pPr>
-            <a:r>
-              <a:rPr lang="en-US" sz="1250" dirty="0">
-                <a:solidFill>
-                  <a:srgbClr val="1C2E22"/>
-                </a:solidFill>
-                <a:latin typeface="Calibri" pitchFamily="34" charset="0"/>
-                <a:ea typeface="Calibri" pitchFamily="34" charset="-122"/>
-                <a:cs typeface="Calibri" pitchFamily="34" charset="-120"/>
-              </a:rPr>
-              <a:t>Fresh produce and a credible organic range are non-negotiable for the core assortment.</a:t>
-            </a:r>
-            <a:endParaRPr lang="en-US" sz="1050" dirty="0"/>
-          </a:p>
-        </p:txBody>
-      </p:sp>
-      <p:sp>
-        <p:nvSpPr>
-          <p:cNvPr id="10" name="Text 7"/>
-          <p:cNvSpPr/>
-          <p:nvPr/>
-        </p:nvSpPr>
-        <p:spPr>
-          <a:xfrm>
-            <a:off x="777240" y="6455664"/>
-            <a:ext cx="7315200" cy="274320"/>
-          </a:xfrm>
-          <a:prstGeom prst="rect">
-            <a:avLst/>
-          </a:prstGeom>
-          <a:noFill/>
-          <a:ln/>
-        </p:spPr>
-        <p:txBody>
-          <a:bodyPr wrap="square" lIns="0" tIns="0" rIns="0" bIns="0" rtlCol="0" anchor="ctr"/>
-          <a:lstStyle/>
-          <a:p>
-            <a:pPr algn="l" indent="0" marL="0">
-              <a:buNone/>
-            </a:pPr>
-            <a:r>
-              <a:rPr lang="en-US" sz="900" dirty="0">
-                <a:solidFill>
-                  <a:srgbClr val="6B7A6E"/>
-                </a:solidFill>
-                <a:latin typeface="Calibri" pitchFamily="34" charset="0"/>
-                <a:ea typeface="Calibri" pitchFamily="34" charset="-122"/>
-                <a:cs typeface="Calibri" pitchFamily="34" charset="-120"/>
-              </a:rPr>
               <a:t>Grocery Product Placement Analysis  ·  Group 11</a:t>
             </a:r>
             <a:endParaRPr lang="en-US" sz="900" dirty="0"/>
@@ -9491,7 +8967,7 @@
       </p:sp>
       <p:sp>
         <p:nvSpPr>
-          <p:cNvPr id="11" name="Text 8"/>
+          <p:cNvPr id="9" name="Text 5"/>
           <p:cNvSpPr/>
           <p:nvPr/>
         </p:nvSpPr>
@@ -9670,30 +9146,16 @@
         </p:nvSpPr>
         <p:spPr>
           <a:xfrm>
-            <a:off x="7315657" y="1874520"/>
-            <a:ext cx="4098798" cy="2971800"/>
-          </a:xfrm>
-          <a:prstGeom prst="roundRect">
-            <a:avLst>
-              <a:gd name="adj" fmla="val 2462"/>
-            </a:avLst>
+            <a:off x="7407097" y="2125980"/>
+            <a:ext cx="64008" cy="3840480"/>
+          </a:xfrm>
+          <a:prstGeom prst="rect">
+            <a:avLst/>
           </a:prstGeom>
           <a:solidFill>
-            <a:srgbClr val="EEF2EC"/>
+            <a:srgbClr val="E07A3F"/>
           </a:solidFill>
-          <a:ln w="12700">
-            <a:solidFill>
-              <a:srgbClr val="D8E0D4"/>
-            </a:solidFill>
-            <a:prstDash val="solid"/>
-          </a:ln>
-          <a:effectLst>
-            <a:outerShdw sx="100000" sy="100000" kx="0" ky="0" algn="bl" rotWithShape="0" blurRad="114300" dist="38100" dir="8100000">
-              <a:srgbClr val="1C2E22">
-                <a:alpha val="16000"/>
-              </a:srgbClr>
-            </a:outerShdw>
-          </a:effectLst>
+          <a:ln/>
         </p:spPr>
       </p:sp>
       <p:sp>
@@ -9704,8 +9166,8 @@
         </p:nvSpPr>
         <p:spPr>
           <a:xfrm>
-            <a:off x="7608265" y="2121408"/>
-            <a:ext cx="3513582" cy="274320"/>
+            <a:off x="7699705" y="1897380"/>
+            <a:ext cx="3714750" cy="4297680"/>
           </a:xfrm>
           <a:prstGeom prst="rect">
             <a:avLst/>
@@ -9718,10 +9180,16 @@
           <a:lstStyle/>
           <a:p>
             <a:pPr indent="0" marL="0">
-              <a:buNone/>
-            </a:pPr>
-            <a:r>
-              <a:rPr lang="en-US" sz="1100" b="1" spc="200" kern="0" dirty="0">
+              <a:lnSpc>
+                <a:spcPts val="2600"/>
+              </a:lnSpc>
+              <a:spcAft>
+                <a:spcPts val="1000"/>
+              </a:spcAft>
+              <a:buNone/>
+            </a:pPr>
+            <a:r>
+              <a:rPr lang="en-US" sz="1150" b="1" spc="200" kern="0" dirty="0">
                 <a:solidFill>
                   <a:srgbClr val="2F6E4F"/>
                 </a:solidFill>
@@ -9729,44 +9197,20 @@
                 <a:ea typeface="Calibri" pitchFamily="34" charset="-122"/>
                 <a:cs typeface="Calibri" pitchFamily="34" charset="-120"/>
               </a:rPr>
-              <a:t>KEY FINDING</a:t>
-            </a:r>
-            <a:endParaRPr lang="en-US" sz="1100" dirty="0"/>
-          </a:p>
-        </p:txBody>
-      </p:sp>
-      <p:sp>
-        <p:nvSpPr>
-          <p:cNvPr id="7" name="Text 4"/>
-          <p:cNvSpPr/>
-          <p:nvPr/>
-        </p:nvSpPr>
-        <p:spPr>
-          <a:xfrm>
-            <a:off x="7608265" y="2432304"/>
-            <a:ext cx="3513582" cy="2286000"/>
-          </a:xfrm>
-          <a:prstGeom prst="rect">
-            <a:avLst/>
-          </a:prstGeom>
-          <a:noFill/>
-          <a:ln/>
-        </p:spPr>
-        <p:txBody>
-          <a:bodyPr wrap="square" lIns="0" tIns="0" rIns="0" bIns="0" rtlCol="0" anchor="t"/>
-          <a:lstStyle/>
-          <a:p>
+              <a:t>WHAT WE FOUND
+</a:t>
+            </a:r>
             <a:pPr indent="0" marL="0">
               <a:lnSpc>
-                <a:spcPts val="1800"/>
+                <a:spcPts val="2600"/>
               </a:lnSpc>
               <a:spcAft>
-                <a:spcPts val="800"/>
+                <a:spcPts val="1000"/>
               </a:spcAft>
               <a:buNone/>
             </a:pPr>
             <a:r>
-              <a:rPr lang="en-US" sz="1600" b="1" dirty="0">
+              <a:rPr lang="en-US" sz="2100" b="1" dirty="0">
                 <a:solidFill>
                   <a:srgbClr val="1C2E22"/>
                 </a:solidFill>
@@ -9776,143 +9220,43 @@
               </a:rPr>
               <a:t>Produce and Dairy &amp; Eggs dwarf every other department.</a:t>
             </a:r>
-            <a:endParaRPr lang="en-US" sz="1600" dirty="0"/>
-          </a:p>
-          <a:p>
-            <a:pPr indent="0" marL="0">
-              <a:lnSpc>
-                <a:spcPts val="1800"/>
-              </a:lnSpc>
-              <a:buNone/>
-            </a:pPr>
-            <a:r>
-              <a:rPr lang="en-US" sz="1250" dirty="0">
-                <a:solidFill>
-                  <a:srgbClr val="1C2E22"/>
+            <a:endParaRPr lang="en-US" sz="1150" dirty="0"/>
+          </a:p>
+        </p:txBody>
+      </p:sp>
+      <p:sp>
+        <p:nvSpPr>
+          <p:cNvPr id="8" name="Text 4"/>
+          <p:cNvSpPr/>
+          <p:nvPr/>
+        </p:nvSpPr>
+        <p:spPr>
+          <a:xfrm>
+            <a:off x="777240" y="6455664"/>
+            <a:ext cx="7315200" cy="274320"/>
+          </a:xfrm>
+          <a:prstGeom prst="rect">
+            <a:avLst/>
+          </a:prstGeom>
+          <a:noFill/>
+          <a:ln/>
+        </p:spPr>
+        <p:txBody>
+          <a:bodyPr wrap="square" lIns="0" tIns="0" rIns="0" bIns="0" rtlCol="0" anchor="ctr"/>
+          <a:lstStyle/>
+          <a:p>
+            <a:pPr algn="l" indent="0" marL="0">
+              <a:buNone/>
+            </a:pPr>
+            <a:r>
+              <a:rPr lang="en-US" sz="900" dirty="0">
+                <a:solidFill>
+                  <a:srgbClr val="6B7A6E"/>
                 </a:solidFill>
                 <a:latin typeface="Calibri" pitchFamily="34" charset="0"/>
                 <a:ea typeface="Calibri" pitchFamily="34" charset="-122"/>
                 <a:cs typeface="Calibri" pitchFamily="34" charset="-120"/>
               </a:rPr>
-              <a:t>Produce drives ~9.5M purchases and Dairy &amp; Eggs ~5.4M. The next tier — snacks, beverages, frozen, pantry — is all convenience food. Bulk, alcohol and pets barely register.</a:t>
-            </a:r>
-            <a:endParaRPr lang="en-US" sz="1600" dirty="0"/>
-          </a:p>
-        </p:txBody>
-      </p:sp>
-      <p:sp>
-        <p:nvSpPr>
-          <p:cNvPr id="8" name="Shape 5"/>
-          <p:cNvSpPr/>
-          <p:nvPr/>
-        </p:nvSpPr>
-        <p:spPr>
-          <a:xfrm>
-            <a:off x="7315657" y="5074920"/>
-            <a:ext cx="64008" cy="1097280"/>
-          </a:xfrm>
-          <a:prstGeom prst="rect">
-            <a:avLst/>
-          </a:prstGeom>
-          <a:solidFill>
-            <a:srgbClr val="E07A3F"/>
-          </a:solidFill>
-          <a:ln/>
-        </p:spPr>
-      </p:sp>
-      <p:sp>
-        <p:nvSpPr>
-          <p:cNvPr id="9" name="Text 6"/>
-          <p:cNvSpPr/>
-          <p:nvPr/>
-        </p:nvSpPr>
-        <p:spPr>
-          <a:xfrm>
-            <a:off x="7562545" y="5074920"/>
-            <a:ext cx="3851910" cy="1097280"/>
-          </a:xfrm>
-          <a:prstGeom prst="rect">
-            <a:avLst/>
-          </a:prstGeom>
-          <a:noFill/>
-          <a:ln/>
-        </p:spPr>
-        <p:txBody>
-          <a:bodyPr wrap="square" lIns="0" tIns="0" rIns="0" bIns="0" rtlCol="0" anchor="t"/>
-          <a:lstStyle/>
-          <a:p>
-            <a:pPr indent="0" marL="0">
-              <a:lnSpc>
-                <a:spcPts val="1600"/>
-              </a:lnSpc>
-              <a:buNone/>
-            </a:pPr>
-            <a:r>
-              <a:rPr lang="en-US" sz="1050" b="1" spc="150" kern="0" dirty="0">
-                <a:solidFill>
-                  <a:srgbClr val="E07A3F"/>
-                </a:solidFill>
-                <a:latin typeface="Calibri" pitchFamily="34" charset="0"/>
-                <a:ea typeface="Calibri" pitchFamily="34" charset="-122"/>
-                <a:cs typeface="Calibri" pitchFamily="34" charset="-120"/>
-              </a:rPr>
-              <a:t>RECOMMENDATION
-</a:t>
-            </a:r>
-            <a:pPr indent="0" marL="0">
-              <a:lnSpc>
-                <a:spcPts val="1600"/>
-              </a:lnSpc>
-              <a:buNone/>
-            </a:pPr>
-            <a:r>
-              <a:rPr lang="en-US" sz="1250" dirty="0">
-                <a:solidFill>
-                  <a:srgbClr val="1C2E22"/>
-                </a:solidFill>
-                <a:latin typeface="Calibri" pitchFamily="34" charset="0"/>
-                <a:ea typeface="Calibri" pitchFamily="34" charset="-122"/>
-                <a:cs typeface="Calibri" pitchFamily="34" charset="-120"/>
-              </a:rPr>
-              <a:t>Anchor the assortment on produce and dairy; treat convenience categories as the growth layer.</a:t>
-            </a:r>
-            <a:endParaRPr lang="en-US" sz="1050" dirty="0"/>
-          </a:p>
-        </p:txBody>
-      </p:sp>
-      <p:sp>
-        <p:nvSpPr>
-          <p:cNvPr id="10" name="Text 7"/>
-          <p:cNvSpPr/>
-          <p:nvPr/>
-        </p:nvSpPr>
-        <p:spPr>
-          <a:xfrm>
-            <a:off x="777240" y="6455664"/>
-            <a:ext cx="7315200" cy="274320"/>
-          </a:xfrm>
-          <a:prstGeom prst="rect">
-            <a:avLst/>
-          </a:prstGeom>
-          <a:noFill/>
-          <a:ln/>
-        </p:spPr>
-        <p:txBody>
-          <a:bodyPr wrap="square" lIns="0" tIns="0" rIns="0" bIns="0" rtlCol="0" anchor="ctr"/>
-          <a:lstStyle/>
-          <a:p>
-            <a:pPr algn="l" indent="0" marL="0">
-              <a:buNone/>
-            </a:pPr>
-            <a:r>
-              <a:rPr lang="en-US" sz="900" dirty="0">
-                <a:solidFill>
-                  <a:srgbClr val="6B7A6E"/>
-                </a:solidFill>
-                <a:latin typeface="Calibri" pitchFamily="34" charset="0"/>
-                <a:ea typeface="Calibri" pitchFamily="34" charset="-122"/>
-                <a:cs typeface="Calibri" pitchFamily="34" charset="-120"/>
-              </a:rPr>
               <a:t>Grocery Product Placement Analysis  ·  Group 11</a:t>
             </a:r>
             <a:endParaRPr lang="en-US" sz="900" dirty="0"/>
@@ -9921,7 +9265,7 @@
       </p:sp>
       <p:sp>
         <p:nvSpPr>
-          <p:cNvPr id="11" name="Text 8"/>
+          <p:cNvPr id="9" name="Text 5"/>
           <p:cNvSpPr/>
           <p:nvPr/>
         </p:nvSpPr>
@@ -10062,54 +9406,30 @@
                 <a:ea typeface="Georgia" pitchFamily="34" charset="-122"/>
                 <a:cs typeface="Georgia" pitchFamily="34" charset="-120"/>
               </a:rPr>
-              <a:t>Co-purchase analysis reveals natural baskets</a:t>
+              <a:t>Grouped by aisle, baskets split by shopping mission</a:t>
             </a:r>
             <a:endParaRPr lang="en-US" sz="3000" dirty="0"/>
           </a:p>
         </p:txBody>
       </p:sp>
-      <p:pic>
-        <p:nvPicPr>
-          <p:cNvPr id="4" name="Image 0" descr="assets/chart_network.png">    </p:cNvPr>
-          <p:cNvPicPr>
-            <a:picLocks noChangeAspect="1"/>
-          </p:cNvPicPr>
-          <p:nvPr/>
-        </p:nvPicPr>
-        <p:blipFill>
-          <a:blip r:embed="rId1"/>
-          <a:stretch>
-            <a:fillRect/>
-          </a:stretch>
-        </p:blipFill>
+      <p:sp>
+        <p:nvSpPr>
+          <p:cNvPr id="4" name="Shape 2"/>
+          <p:cNvSpPr/>
+          <p:nvPr/>
+        </p:nvSpPr>
         <p:spPr>
           <a:xfrm>
             <a:off x="777240" y="1810512"/>
-            <a:ext cx="5845119" cy="4434840"/>
-          </a:xfrm>
-          <a:prstGeom prst="rect">
-            <a:avLst/>
-          </a:prstGeom>
-        </p:spPr>
-      </p:pic>
-      <p:sp>
-        <p:nvSpPr>
-          <p:cNvPr id="5" name="Shape 2"/>
-          <p:cNvSpPr/>
-          <p:nvPr/>
-        </p:nvSpPr>
-        <p:spPr>
-          <a:xfrm>
-            <a:off x="7079559" y="1810512"/>
-            <a:ext cx="4334896" cy="3310128"/>
+            <a:ext cx="5029200" cy="2029968"/>
           </a:xfrm>
           <a:prstGeom prst="roundRect">
             <a:avLst>
-              <a:gd name="adj" fmla="val 2210"/>
+              <a:gd name="adj" fmla="val 3153"/>
             </a:avLst>
           </a:prstGeom>
           <a:solidFill>
-            <a:srgbClr val="EEF2EC"/>
+            <a:srgbClr val="FFFFFF"/>
           </a:solidFill>
           <a:ln w="12700">
             <a:solidFill>
@@ -10128,14 +9448,54 @@
       </p:sp>
       <p:sp>
         <p:nvSpPr>
-          <p:cNvPr id="6" name="Text 3"/>
-          <p:cNvSpPr/>
-          <p:nvPr/>
-        </p:nvSpPr>
-        <p:spPr>
-          <a:xfrm>
-            <a:off x="7372167" y="2048256"/>
-            <a:ext cx="3749680" cy="274320"/>
+          <p:cNvPr id="5" name="Shape 3"/>
+          <p:cNvSpPr/>
+          <p:nvPr/>
+        </p:nvSpPr>
+        <p:spPr>
+          <a:xfrm>
+            <a:off x="777240" y="1810512"/>
+            <a:ext cx="5029200" cy="100584"/>
+          </a:xfrm>
+          <a:prstGeom prst="rect">
+            <a:avLst/>
+          </a:prstGeom>
+          <a:solidFill>
+            <a:srgbClr val="2F6E4F"/>
+          </a:solidFill>
+          <a:ln/>
+        </p:spPr>
+      </p:sp>
+      <p:sp>
+        <p:nvSpPr>
+          <p:cNvPr id="6" name="Shape 4"/>
+          <p:cNvSpPr/>
+          <p:nvPr/>
+        </p:nvSpPr>
+        <p:spPr>
+          <a:xfrm>
+            <a:off x="1069848" y="2139696"/>
+            <a:ext cx="182880" cy="182880"/>
+          </a:xfrm>
+          <a:prstGeom prst="ellipse">
+            <a:avLst/>
+          </a:prstGeom>
+          <a:solidFill>
+            <a:srgbClr val="2F6E4F"/>
+          </a:solidFill>
+          <a:ln/>
+        </p:spPr>
+      </p:sp>
+      <p:sp>
+        <p:nvSpPr>
+          <p:cNvPr id="7" name="Text 5"/>
+          <p:cNvSpPr/>
+          <p:nvPr/>
+        </p:nvSpPr>
+        <p:spPr>
+          <a:xfrm>
+            <a:off x="1344168" y="2066544"/>
+            <a:ext cx="3291840" cy="365760"/>
           </a:xfrm>
           <a:prstGeom prst="rect">
             <a:avLst/>
@@ -10151,7 +9511,46 @@
               <a:buNone/>
             </a:pPr>
             <a:r>
-              <a:rPr lang="en-US" sz="1100" b="1" spc="200" kern="0" dirty="0">
+              <a:rPr lang="en-US" sz="1700" b="1" dirty="0">
+                <a:solidFill>
+                  <a:srgbClr val="1C2E22"/>
+                </a:solidFill>
+                <a:latin typeface="Georgia" pitchFamily="34" charset="0"/>
+                <a:ea typeface="Georgia" pitchFamily="34" charset="-122"/>
+                <a:cs typeface="Georgia" pitchFamily="34" charset="-120"/>
+              </a:rPr>
+              <a:t>The cooking basket</a:t>
+            </a:r>
+            <a:endParaRPr lang="en-US" sz="1700" dirty="0"/>
+          </a:p>
+        </p:txBody>
+      </p:sp>
+      <p:sp>
+        <p:nvSpPr>
+          <p:cNvPr id="8" name="Text 6"/>
+          <p:cNvSpPr/>
+          <p:nvPr/>
+        </p:nvSpPr>
+        <p:spPr>
+          <a:xfrm>
+            <a:off x="4343400" y="2066544"/>
+            <a:ext cx="1280160" cy="365760"/>
+          </a:xfrm>
+          <a:prstGeom prst="rect">
+            <a:avLst/>
+          </a:prstGeom>
+          <a:noFill/>
+          <a:ln/>
+        </p:spPr>
+        <p:txBody>
+          <a:bodyPr wrap="square" lIns="0" tIns="0" rIns="0" bIns="0" rtlCol="0" anchor="ctr"/>
+          <a:lstStyle/>
+          <a:p>
+            <a:pPr algn="r" indent="0" marL="0">
+              <a:buNone/>
+            </a:pPr>
+            <a:r>
+              <a:rPr lang="en-US" sz="1100" b="1" spc="100" kern="0" dirty="0">
                 <a:solidFill>
                   <a:srgbClr val="2F6E4F"/>
                 </a:solidFill>
@@ -10159,7 +9558,7 @@
                 <a:ea typeface="Calibri" pitchFamily="34" charset="-122"/>
                 <a:cs typeface="Calibri" pitchFamily="34" charset="-120"/>
               </a:rPr>
-              <a:t>KEY FINDING</a:t>
+              <a:t>60 AISLES</a:t>
             </a:r>
             <a:endParaRPr lang="en-US" sz="1100" dirty="0"/>
           </a:p>
@@ -10167,14 +9566,14 @@
       </p:sp>
       <p:sp>
         <p:nvSpPr>
-          <p:cNvPr id="7" name="Text 4"/>
-          <p:cNvSpPr/>
-          <p:nvPr/>
-        </p:nvSpPr>
-        <p:spPr>
-          <a:xfrm>
-            <a:off x="7372167" y="2322576"/>
-            <a:ext cx="3749680" cy="914400"/>
+          <p:cNvPr id="9" name="Text 7"/>
+          <p:cNvSpPr/>
+          <p:nvPr/>
+        </p:nvSpPr>
+        <p:spPr>
+          <a:xfrm>
+            <a:off x="1088136" y="2560320"/>
+            <a:ext cx="4434840" cy="1188720"/>
           </a:xfrm>
           <a:prstGeom prst="rect">
             <a:avLst/>
@@ -10201,7 +9600,7 @@
                 <a:ea typeface="Calibri" pitchFamily="34" charset="-122"/>
                 <a:cs typeface="Calibri" pitchFamily="34" charset="-120"/>
               </a:rPr>
-              <a:t>Products bought together far more than chance form three clear clusters among the 500 most-purchased items (lift ≥ 2):</a:t>
+              <a:t>Fresh fruit &amp; vegetables, milk, eggs, bread, cheese, yoghurt, meat — plus dry pasta, pasta sauce, oils, spices and the rest of the cook-from-scratch pantry.</a:t>
             </a:r>
             <a:endParaRPr lang="en-US" sz="1250" dirty="0"/>
           </a:p>
@@ -10209,357 +9608,619 @@
       </p:sp>
       <p:sp>
         <p:nvSpPr>
-          <p:cNvPr id="8" name="Shape 5"/>
-          <p:cNvSpPr/>
-          <p:nvPr/>
-        </p:nvSpPr>
-        <p:spPr>
-          <a:xfrm>
-            <a:off x="7390455" y="3374136"/>
-            <a:ext cx="164592" cy="164592"/>
+          <p:cNvPr id="10" name="Shape 8"/>
+          <p:cNvSpPr/>
+          <p:nvPr/>
+        </p:nvSpPr>
+        <p:spPr>
+          <a:xfrm>
+            <a:off x="6355080" y="1810512"/>
+            <a:ext cx="5029200" cy="2029968"/>
+          </a:xfrm>
+          <a:prstGeom prst="roundRect">
+            <a:avLst>
+              <a:gd name="adj" fmla="val 3153"/>
+            </a:avLst>
+          </a:prstGeom>
+          <a:solidFill>
+            <a:srgbClr val="FFFFFF"/>
+          </a:solidFill>
+          <a:ln w="12700">
+            <a:solidFill>
+              <a:srgbClr val="D8E0D4"/>
+            </a:solidFill>
+            <a:prstDash val="solid"/>
+          </a:ln>
+          <a:effectLst>
+            <a:outerShdw sx="100000" sy="100000" kx="0" ky="0" algn="bl" rotWithShape="0" blurRad="114300" dist="38100" dir="8100000">
+              <a:srgbClr val="1C2E22">
+                <a:alpha val="16000"/>
+              </a:srgbClr>
+            </a:outerShdw>
+          </a:effectLst>
+        </p:spPr>
+      </p:sp>
+      <p:sp>
+        <p:nvSpPr>
+          <p:cNvPr id="11" name="Shape 9"/>
+          <p:cNvSpPr/>
+          <p:nvPr/>
+        </p:nvSpPr>
+        <p:spPr>
+          <a:xfrm>
+            <a:off x="6355080" y="1810512"/>
+            <a:ext cx="5029200" cy="100584"/>
+          </a:xfrm>
+          <a:prstGeom prst="rect">
+            <a:avLst/>
+          </a:prstGeom>
+          <a:solidFill>
+            <a:srgbClr val="E07A3F"/>
+          </a:solidFill>
+          <a:ln/>
+        </p:spPr>
+      </p:sp>
+      <p:sp>
+        <p:nvSpPr>
+          <p:cNvPr id="12" name="Shape 10"/>
+          <p:cNvSpPr/>
+          <p:nvPr/>
+        </p:nvSpPr>
+        <p:spPr>
+          <a:xfrm>
+            <a:off x="6647688" y="2139696"/>
+            <a:ext cx="182880" cy="182880"/>
           </a:xfrm>
           <a:prstGeom prst="ellipse">
             <a:avLst/>
           </a:prstGeom>
           <a:solidFill>
-            <a:srgbClr val="2F6E4F"/>
+            <a:srgbClr val="E07A3F"/>
           </a:solidFill>
           <a:ln/>
         </p:spPr>
       </p:sp>
       <p:sp>
         <p:nvSpPr>
-          <p:cNvPr id="9" name="Text 6"/>
-          <p:cNvSpPr/>
-          <p:nvPr/>
-        </p:nvSpPr>
-        <p:spPr>
-          <a:xfrm>
-            <a:off x="7664775" y="3310128"/>
-            <a:ext cx="3420496" cy="566928"/>
-          </a:xfrm>
-          <a:prstGeom prst="rect">
-            <a:avLst/>
-          </a:prstGeom>
-          <a:noFill/>
-          <a:ln/>
-        </p:spPr>
-        <p:txBody>
-          <a:bodyPr wrap="square" lIns="0" tIns="0" rIns="0" bIns="0" rtlCol="0" anchor="t"/>
+          <p:cNvPr id="13" name="Text 11"/>
+          <p:cNvSpPr/>
+          <p:nvPr/>
+        </p:nvSpPr>
+        <p:spPr>
+          <a:xfrm>
+            <a:off x="6922008" y="2066544"/>
+            <a:ext cx="3291840" cy="365760"/>
+          </a:xfrm>
+          <a:prstGeom prst="rect">
+            <a:avLst/>
+          </a:prstGeom>
+          <a:noFill/>
+          <a:ln/>
+        </p:spPr>
+        <p:txBody>
+          <a:bodyPr wrap="square" lIns="0" tIns="0" rIns="0" bIns="0" rtlCol="0" anchor="ctr"/>
           <a:lstStyle/>
           <a:p>
             <a:pPr indent="0" marL="0">
-              <a:lnSpc>
-                <a:spcPts val="1300"/>
-              </a:lnSpc>
-              <a:buNone/>
-            </a:pPr>
-            <a:r>
-              <a:rPr lang="en-US" sz="1200" b="1" dirty="0">
+              <a:buNone/>
+            </a:pPr>
+            <a:r>
+              <a:rPr lang="en-US" sz="1700" b="1" dirty="0">
                 <a:solidFill>
                   <a:srgbClr val="1C2E22"/>
+                </a:solidFill>
+                <a:latin typeface="Georgia" pitchFamily="34" charset="0"/>
+                <a:ea typeface="Georgia" pitchFamily="34" charset="-122"/>
+                <a:cs typeface="Georgia" pitchFamily="34" charset="-120"/>
+              </a:rPr>
+              <a:t>The convenience &amp; household run</a:t>
+            </a:r>
+            <a:endParaRPr lang="en-US" sz="1700" dirty="0"/>
+          </a:p>
+        </p:txBody>
+      </p:sp>
+      <p:sp>
+        <p:nvSpPr>
+          <p:cNvPr id="14" name="Text 12"/>
+          <p:cNvSpPr/>
+          <p:nvPr/>
+        </p:nvSpPr>
+        <p:spPr>
+          <a:xfrm>
+            <a:off x="9921240" y="2066544"/>
+            <a:ext cx="1280160" cy="365760"/>
+          </a:xfrm>
+          <a:prstGeom prst="rect">
+            <a:avLst/>
+          </a:prstGeom>
+          <a:noFill/>
+          <a:ln/>
+        </p:spPr>
+        <p:txBody>
+          <a:bodyPr wrap="square" lIns="0" tIns="0" rIns="0" bIns="0" rtlCol="0" anchor="ctr"/>
+          <a:lstStyle/>
+          <a:p>
+            <a:pPr algn="r" indent="0" marL="0">
+              <a:buNone/>
+            </a:pPr>
+            <a:r>
+              <a:rPr lang="en-US" sz="1100" b="1" spc="100" kern="0" dirty="0">
+                <a:solidFill>
+                  <a:srgbClr val="E07A3F"/>
                 </a:solidFill>
                 <a:latin typeface="Calibri" pitchFamily="34" charset="0"/>
                 <a:ea typeface="Calibri" pitchFamily="34" charset="-122"/>
                 <a:cs typeface="Calibri" pitchFamily="34" charset="-120"/>
               </a:rPr>
-              <a:t>Fresh vegetables &amp; aromatics
-</a:t>
-            </a:r>
+              <a:t>59 AISLES</a:t>
+            </a:r>
+            <a:endParaRPr lang="en-US" sz="1100" dirty="0"/>
+          </a:p>
+        </p:txBody>
+      </p:sp>
+      <p:sp>
+        <p:nvSpPr>
+          <p:cNvPr id="15" name="Text 13"/>
+          <p:cNvSpPr/>
+          <p:nvPr/>
+        </p:nvSpPr>
+        <p:spPr>
+          <a:xfrm>
+            <a:off x="6665976" y="2560320"/>
+            <a:ext cx="4434840" cy="1188720"/>
+          </a:xfrm>
+          <a:prstGeom prst="rect">
+            <a:avLst/>
+          </a:prstGeom>
+          <a:noFill/>
+          <a:ln/>
+        </p:spPr>
+        <p:txBody>
+          <a:bodyPr wrap="square" lIns="0" tIns="0" rIns="0" bIns="0" rtlCol="0" anchor="t"/>
+          <a:lstStyle/>
+          <a:p>
             <a:pPr indent="0" marL="0">
               <a:lnSpc>
-                <a:spcPts val="1300"/>
+                <a:spcPts val="1700"/>
               </a:lnSpc>
               <a:buNone/>
             </a:pPr>
             <a:r>
-              <a:rPr lang="en-US" sz="1050" dirty="0">
-                <a:solidFill>
-                  <a:srgbClr val="6B7A6E"/>
+              <a:rPr lang="en-US" sz="1250" dirty="0">
+                <a:solidFill>
+                  <a:srgbClr val="1C2E22"/>
                 </a:solidFill>
                 <a:latin typeface="Calibri" pitchFamily="34" charset="0"/>
                 <a:ea typeface="Calibri" pitchFamily="34" charset="-122"/>
                 <a:cs typeface="Calibri" pitchFamily="34" charset="-120"/>
               </a:rPr>
-              <a:t>spinach, avocado, onion, garlic, lemon</a:t>
-            </a:r>
-            <a:endParaRPr lang="en-US" sz="1200" dirty="0"/>
-          </a:p>
-        </p:txBody>
-      </p:sp>
-      <p:sp>
-        <p:nvSpPr>
-          <p:cNvPr id="10" name="Shape 7"/>
-          <p:cNvSpPr/>
-          <p:nvPr/>
-        </p:nvSpPr>
-        <p:spPr>
-          <a:xfrm>
-            <a:off x="7390455" y="3959352"/>
-            <a:ext cx="164592" cy="164592"/>
+              <a:t>Water, chips &amp; pretzels, crackers, ice cream, cereal, soft drinks, candy, frozen meals &amp; pizza — alongside paper goods and cleaning products.</a:t>
+            </a:r>
+            <a:endParaRPr lang="en-US" sz="1250" dirty="0"/>
+          </a:p>
+        </p:txBody>
+      </p:sp>
+      <p:sp>
+        <p:nvSpPr>
+          <p:cNvPr id="16" name="Shape 14"/>
+          <p:cNvSpPr/>
+          <p:nvPr/>
+        </p:nvSpPr>
+        <p:spPr>
+          <a:xfrm>
+            <a:off x="777240" y="4005072"/>
+            <a:ext cx="5029200" cy="2029968"/>
+          </a:xfrm>
+          <a:prstGeom prst="roundRect">
+            <a:avLst>
+              <a:gd name="adj" fmla="val 3153"/>
+            </a:avLst>
+          </a:prstGeom>
+          <a:solidFill>
+            <a:srgbClr val="FFFFFF"/>
+          </a:solidFill>
+          <a:ln w="12700">
+            <a:solidFill>
+              <a:srgbClr val="D8E0D4"/>
+            </a:solidFill>
+            <a:prstDash val="solid"/>
+          </a:ln>
+          <a:effectLst>
+            <a:outerShdw sx="100000" sy="100000" kx="0" ky="0" algn="bl" rotWithShape="0" blurRad="114300" dist="38100" dir="8100000">
+              <a:srgbClr val="1C2E22">
+                <a:alpha val="16000"/>
+              </a:srgbClr>
+            </a:outerShdw>
+          </a:effectLst>
+        </p:spPr>
+      </p:sp>
+      <p:sp>
+        <p:nvSpPr>
+          <p:cNvPr id="17" name="Shape 15"/>
+          <p:cNvSpPr/>
+          <p:nvPr/>
+        </p:nvSpPr>
+        <p:spPr>
+          <a:xfrm>
+            <a:off x="777240" y="4005072"/>
+            <a:ext cx="5029200" cy="100584"/>
+          </a:xfrm>
+          <a:prstGeom prst="rect">
+            <a:avLst/>
+          </a:prstGeom>
+          <a:solidFill>
+            <a:srgbClr val="5B8DB8"/>
+          </a:solidFill>
+          <a:ln/>
+        </p:spPr>
+      </p:sp>
+      <p:sp>
+        <p:nvSpPr>
+          <p:cNvPr id="18" name="Shape 16"/>
+          <p:cNvSpPr/>
+          <p:nvPr/>
+        </p:nvSpPr>
+        <p:spPr>
+          <a:xfrm>
+            <a:off x="1069848" y="4334256"/>
+            <a:ext cx="182880" cy="182880"/>
           </a:xfrm>
           <a:prstGeom prst="ellipse">
             <a:avLst/>
           </a:prstGeom>
           <a:solidFill>
-            <a:srgbClr val="E07A3F"/>
+            <a:srgbClr val="5B8DB8"/>
           </a:solidFill>
           <a:ln/>
         </p:spPr>
       </p:sp>
       <p:sp>
         <p:nvSpPr>
-          <p:cNvPr id="11" name="Text 8"/>
-          <p:cNvSpPr/>
-          <p:nvPr/>
-        </p:nvSpPr>
-        <p:spPr>
-          <a:xfrm>
-            <a:off x="7664775" y="3895344"/>
-            <a:ext cx="3420496" cy="566928"/>
-          </a:xfrm>
-          <a:prstGeom prst="rect">
-            <a:avLst/>
-          </a:prstGeom>
-          <a:noFill/>
-          <a:ln/>
-        </p:spPr>
-        <p:txBody>
-          <a:bodyPr wrap="square" lIns="0" tIns="0" rIns="0" bIns="0" rtlCol="0" anchor="t"/>
+          <p:cNvPr id="19" name="Text 17"/>
+          <p:cNvSpPr/>
+          <p:nvPr/>
+        </p:nvSpPr>
+        <p:spPr>
+          <a:xfrm>
+            <a:off x="1344168" y="4261104"/>
+            <a:ext cx="3291840" cy="365760"/>
+          </a:xfrm>
+          <a:prstGeom prst="rect">
+            <a:avLst/>
+          </a:prstGeom>
+          <a:noFill/>
+          <a:ln/>
+        </p:spPr>
+        <p:txBody>
+          <a:bodyPr wrap="square" lIns="0" tIns="0" rIns="0" bIns="0" rtlCol="0" anchor="ctr"/>
           <a:lstStyle/>
           <a:p>
             <a:pPr indent="0" marL="0">
-              <a:lnSpc>
-                <a:spcPts val="1300"/>
-              </a:lnSpc>
-              <a:buNone/>
-            </a:pPr>
-            <a:r>
-              <a:rPr lang="en-US" sz="1200" b="1" dirty="0">
+              <a:buNone/>
+            </a:pPr>
+            <a:r>
+              <a:rPr lang="en-US" sz="1700" b="1" dirty="0">
                 <a:solidFill>
                   <a:srgbClr val="1C2E22"/>
+                </a:solidFill>
+                <a:latin typeface="Georgia" pitchFamily="34" charset="0"/>
+                <a:ea typeface="Georgia" pitchFamily="34" charset="-122"/>
+                <a:cs typeface="Georgia" pitchFamily="34" charset="-120"/>
+              </a:rPr>
+              <a:t>The drinks run</a:t>
+            </a:r>
+            <a:endParaRPr lang="en-US" sz="1700" dirty="0"/>
+          </a:p>
+        </p:txBody>
+      </p:sp>
+      <p:sp>
+        <p:nvSpPr>
+          <p:cNvPr id="20" name="Text 18"/>
+          <p:cNvSpPr/>
+          <p:nvPr/>
+        </p:nvSpPr>
+        <p:spPr>
+          <a:xfrm>
+            <a:off x="4343400" y="4261104"/>
+            <a:ext cx="1280160" cy="365760"/>
+          </a:xfrm>
+          <a:prstGeom prst="rect">
+            <a:avLst/>
+          </a:prstGeom>
+          <a:noFill/>
+          <a:ln/>
+        </p:spPr>
+        <p:txBody>
+          <a:bodyPr wrap="square" lIns="0" tIns="0" rIns="0" bIns="0" rtlCol="0" anchor="ctr"/>
+          <a:lstStyle/>
+          <a:p>
+            <a:pPr algn="r" indent="0" marL="0">
+              <a:buNone/>
+            </a:pPr>
+            <a:r>
+              <a:rPr lang="en-US" sz="1100" b="1" spc="100" kern="0" dirty="0">
+                <a:solidFill>
+                  <a:srgbClr val="5B8DB8"/>
                 </a:solidFill>
                 <a:latin typeface="Calibri" pitchFamily="34" charset="0"/>
                 <a:ea typeface="Calibri" pitchFamily="34" charset="-122"/>
                 <a:cs typeface="Calibri" pitchFamily="34" charset="-120"/>
               </a:rPr>
-              <a:t>Everyday fruit &amp; milk
-</a:t>
-            </a:r>
+              <a:t>5 AISLES</a:t>
+            </a:r>
+            <a:endParaRPr lang="en-US" sz="1100" dirty="0"/>
+          </a:p>
+        </p:txBody>
+      </p:sp>
+      <p:sp>
+        <p:nvSpPr>
+          <p:cNvPr id="21" name="Text 19"/>
+          <p:cNvSpPr/>
+          <p:nvPr/>
+        </p:nvSpPr>
+        <p:spPr>
+          <a:xfrm>
+            <a:off x="1088136" y="4754880"/>
+            <a:ext cx="4434840" cy="1188720"/>
+          </a:xfrm>
+          <a:prstGeom prst="rect">
+            <a:avLst/>
+          </a:prstGeom>
+          <a:noFill/>
+          <a:ln/>
+        </p:spPr>
+        <p:txBody>
+          <a:bodyPr wrap="square" lIns="0" tIns="0" rIns="0" bIns="0" rtlCol="0" anchor="t"/>
+          <a:lstStyle/>
+          <a:p>
             <a:pPr indent="0" marL="0">
               <a:lnSpc>
-                <a:spcPts val="1300"/>
+                <a:spcPts val="1700"/>
               </a:lnSpc>
               <a:buNone/>
             </a:pPr>
             <a:r>
-              <a:rPr lang="en-US" sz="1050" dirty="0">
-                <a:solidFill>
-                  <a:srgbClr val="6B7A6E"/>
+              <a:rPr lang="en-US" sz="1250" dirty="0">
+                <a:solidFill>
+                  <a:srgbClr val="1C2E22"/>
                 </a:solidFill>
                 <a:latin typeface="Calibri" pitchFamily="34" charset="0"/>
                 <a:ea typeface="Calibri" pitchFamily="34" charset="-122"/>
                 <a:cs typeface="Calibri" pitchFamily="34" charset="-120"/>
               </a:rPr>
-              <a:t>banana, berries, apples, whole milk</a:t>
-            </a:r>
-            <a:endParaRPr lang="en-US" sz="1200" dirty="0"/>
-          </a:p>
-        </p:txBody>
-      </p:sp>
-      <p:sp>
-        <p:nvSpPr>
-          <p:cNvPr id="12" name="Shape 9"/>
-          <p:cNvSpPr/>
-          <p:nvPr/>
-        </p:nvSpPr>
-        <p:spPr>
-          <a:xfrm>
-            <a:off x="7390455" y="4544568"/>
-            <a:ext cx="164592" cy="164592"/>
+              <a:t>Beer, red &amp; white wine, spirits and champagne — bought together, and largely on their own.</a:t>
+            </a:r>
+            <a:endParaRPr lang="en-US" sz="1250" dirty="0"/>
+          </a:p>
+        </p:txBody>
+      </p:sp>
+      <p:sp>
+        <p:nvSpPr>
+          <p:cNvPr id="22" name="Shape 20"/>
+          <p:cNvSpPr/>
+          <p:nvPr/>
+        </p:nvSpPr>
+        <p:spPr>
+          <a:xfrm>
+            <a:off x="6355080" y="4005072"/>
+            <a:ext cx="5029200" cy="2029968"/>
+          </a:xfrm>
+          <a:prstGeom prst="roundRect">
+            <a:avLst>
+              <a:gd name="adj" fmla="val 3153"/>
+            </a:avLst>
+          </a:prstGeom>
+          <a:solidFill>
+            <a:srgbClr val="FFFFFF"/>
+          </a:solidFill>
+          <a:ln w="12700">
+            <a:solidFill>
+              <a:srgbClr val="D8E0D4"/>
+            </a:solidFill>
+            <a:prstDash val="solid"/>
+          </a:ln>
+          <a:effectLst>
+            <a:outerShdw sx="100000" sy="100000" kx="0" ky="0" algn="bl" rotWithShape="0" blurRad="114300" dist="38100" dir="8100000">
+              <a:srgbClr val="1C2E22">
+                <a:alpha val="16000"/>
+              </a:srgbClr>
+            </a:outerShdw>
+          </a:effectLst>
+        </p:spPr>
+      </p:sp>
+      <p:sp>
+        <p:nvSpPr>
+          <p:cNvPr id="23" name="Shape 21"/>
+          <p:cNvSpPr/>
+          <p:nvPr/>
+        </p:nvSpPr>
+        <p:spPr>
+          <a:xfrm>
+            <a:off x="6355080" y="4005072"/>
+            <a:ext cx="5029200" cy="100584"/>
+          </a:xfrm>
+          <a:prstGeom prst="rect">
+            <a:avLst/>
+          </a:prstGeom>
+          <a:solidFill>
+            <a:srgbClr val="C9A227"/>
+          </a:solidFill>
+          <a:ln/>
+        </p:spPr>
+      </p:sp>
+      <p:sp>
+        <p:nvSpPr>
+          <p:cNvPr id="24" name="Shape 22"/>
+          <p:cNvSpPr/>
+          <p:nvPr/>
+        </p:nvSpPr>
+        <p:spPr>
+          <a:xfrm>
+            <a:off x="6647688" y="4334256"/>
+            <a:ext cx="182880" cy="182880"/>
           </a:xfrm>
           <a:prstGeom prst="ellipse">
             <a:avLst/>
           </a:prstGeom>
           <a:solidFill>
-            <a:srgbClr val="5B8DB8"/>
+            <a:srgbClr val="C9A227"/>
           </a:solidFill>
           <a:ln/>
         </p:spPr>
       </p:sp>
       <p:sp>
         <p:nvSpPr>
-          <p:cNvPr id="13" name="Text 10"/>
-          <p:cNvSpPr/>
-          <p:nvPr/>
-        </p:nvSpPr>
-        <p:spPr>
-          <a:xfrm>
-            <a:off x="7664775" y="4480560"/>
-            <a:ext cx="3420496" cy="566928"/>
-          </a:xfrm>
-          <a:prstGeom prst="rect">
-            <a:avLst/>
-          </a:prstGeom>
-          <a:noFill/>
-          <a:ln/>
-        </p:spPr>
-        <p:txBody>
-          <a:bodyPr wrap="square" lIns="0" tIns="0" rIns="0" bIns="0" rtlCol="0" anchor="t"/>
+          <p:cNvPr id="25" name="Text 23"/>
+          <p:cNvSpPr/>
+          <p:nvPr/>
+        </p:nvSpPr>
+        <p:spPr>
+          <a:xfrm>
+            <a:off x="6922008" y="4261104"/>
+            <a:ext cx="3291840" cy="365760"/>
+          </a:xfrm>
+          <a:prstGeom prst="rect">
+            <a:avLst/>
+          </a:prstGeom>
+          <a:noFill/>
+          <a:ln/>
+        </p:spPr>
+        <p:txBody>
+          <a:bodyPr wrap="square" lIns="0" tIns="0" rIns="0" bIns="0" rtlCol="0" anchor="ctr"/>
           <a:lstStyle/>
           <a:p>
             <a:pPr indent="0" marL="0">
-              <a:lnSpc>
-                <a:spcPts val="1300"/>
-              </a:lnSpc>
-              <a:buNone/>
-            </a:pPr>
-            <a:r>
-              <a:rPr lang="en-US" sz="1200" b="1" dirty="0">
+              <a:buNone/>
+            </a:pPr>
+            <a:r>
+              <a:rPr lang="en-US" sz="1700" b="1" dirty="0">
                 <a:solidFill>
                   <a:srgbClr val="1C2E22"/>
+                </a:solidFill>
+                <a:latin typeface="Georgia" pitchFamily="34" charset="0"/>
+                <a:ea typeface="Georgia" pitchFamily="34" charset="-122"/>
+                <a:cs typeface="Georgia" pitchFamily="34" charset="-120"/>
+              </a:rPr>
+              <a:t>Health &amp; bulk</a:t>
+            </a:r>
+            <a:endParaRPr lang="en-US" sz="1700" dirty="0"/>
+          </a:p>
+        </p:txBody>
+      </p:sp>
+      <p:sp>
+        <p:nvSpPr>
+          <p:cNvPr id="26" name="Text 24"/>
+          <p:cNvSpPr/>
+          <p:nvPr/>
+        </p:nvSpPr>
+        <p:spPr>
+          <a:xfrm>
+            <a:off x="9921240" y="4261104"/>
+            <a:ext cx="1280160" cy="365760"/>
+          </a:xfrm>
+          <a:prstGeom prst="rect">
+            <a:avLst/>
+          </a:prstGeom>
+          <a:noFill/>
+          <a:ln/>
+        </p:spPr>
+        <p:txBody>
+          <a:bodyPr wrap="square" lIns="0" tIns="0" rIns="0" bIns="0" rtlCol="0" anchor="ctr"/>
+          <a:lstStyle/>
+          <a:p>
+            <a:pPr algn="r" indent="0" marL="0">
+              <a:buNone/>
+            </a:pPr>
+            <a:r>
+              <a:rPr lang="en-US" sz="1100" b="1" spc="100" kern="0" dirty="0">
+                <a:solidFill>
+                  <a:srgbClr val="C9A227"/>
                 </a:solidFill>
                 <a:latin typeface="Calibri" pitchFamily="34" charset="0"/>
                 <a:ea typeface="Calibri" pitchFamily="34" charset="-122"/>
                 <a:cs typeface="Calibri" pitchFamily="34" charset="-120"/>
               </a:rPr>
-              <a:t>The organic basket
-</a:t>
-            </a:r>
+              <a:t>4 AISLES</a:t>
+            </a:r>
+            <a:endParaRPr lang="en-US" sz="1100" dirty="0"/>
+          </a:p>
+        </p:txBody>
+      </p:sp>
+      <p:sp>
+        <p:nvSpPr>
+          <p:cNvPr id="27" name="Text 25"/>
+          <p:cNvSpPr/>
+          <p:nvPr/>
+        </p:nvSpPr>
+        <p:spPr>
+          <a:xfrm>
+            <a:off x="6665976" y="4754880"/>
+            <a:ext cx="4434840" cy="1188720"/>
+          </a:xfrm>
+          <a:prstGeom prst="rect">
+            <a:avLst/>
+          </a:prstGeom>
+          <a:noFill/>
+          <a:ln/>
+        </p:spPr>
+        <p:txBody>
+          <a:bodyPr wrap="square" lIns="0" tIns="0" rIns="0" bIns="0" rtlCol="0" anchor="t"/>
+          <a:lstStyle/>
+          <a:p>
             <a:pPr indent="0" marL="0">
               <a:lnSpc>
-                <a:spcPts val="1300"/>
+                <a:spcPts val="1700"/>
               </a:lnSpc>
               <a:buNone/>
             </a:pPr>
             <a:r>
-              <a:rPr lang="en-US" sz="1050" dirty="0">
-                <a:solidFill>
-                  <a:srgbClr val="6B7A6E"/>
+              <a:rPr lang="en-US" sz="1250" dirty="0">
+                <a:solidFill>
+                  <a:srgbClr val="1C2E22"/>
                 </a:solidFill>
                 <a:latin typeface="Calibri" pitchFamily="34" charset="0"/>
                 <a:ea typeface="Calibri" pitchFamily="34" charset="-122"/>
                 <a:cs typeface="Calibri" pitchFamily="34" charset="-120"/>
               </a:rPr>
-              <a:t>organic bananas, berries, almond milk</a:t>
-            </a:r>
-            <a:endParaRPr lang="en-US" sz="1200" dirty="0"/>
-          </a:p>
-        </p:txBody>
-      </p:sp>
-      <p:sp>
-        <p:nvSpPr>
-          <p:cNvPr id="14" name="Shape 11"/>
-          <p:cNvSpPr/>
-          <p:nvPr/>
-        </p:nvSpPr>
-        <p:spPr>
-          <a:xfrm>
-            <a:off x="7079559" y="5349240"/>
-            <a:ext cx="64008" cy="914400"/>
-          </a:xfrm>
-          <a:prstGeom prst="rect">
-            <a:avLst/>
-          </a:prstGeom>
-          <a:solidFill>
-            <a:srgbClr val="E07A3F"/>
-          </a:solidFill>
-          <a:ln/>
-        </p:spPr>
-      </p:sp>
-      <p:sp>
-        <p:nvSpPr>
-          <p:cNvPr id="15" name="Text 12"/>
-          <p:cNvSpPr/>
-          <p:nvPr/>
-        </p:nvSpPr>
-        <p:spPr>
-          <a:xfrm>
-            <a:off x="7326447" y="5349240"/>
-            <a:ext cx="4088008" cy="914400"/>
-          </a:xfrm>
-          <a:prstGeom prst="rect">
-            <a:avLst/>
-          </a:prstGeom>
-          <a:noFill/>
-          <a:ln/>
-        </p:spPr>
-        <p:txBody>
-          <a:bodyPr wrap="square" lIns="0" tIns="0" rIns="0" bIns="0" rtlCol="0" anchor="t"/>
-          <a:lstStyle/>
-          <a:p>
-            <a:pPr indent="0" marL="0">
-              <a:lnSpc>
-                <a:spcPts val="1600"/>
-              </a:lnSpc>
-              <a:buNone/>
-            </a:pPr>
-            <a:r>
-              <a:rPr lang="en-US" sz="1050" b="1" spc="150" kern="0" dirty="0">
-                <a:solidFill>
-                  <a:srgbClr val="E07A3F"/>
+              <a:t>Nuts &amp; dried fruit, bulk dried fruit &amp; veg, vitamins &amp; supplements, packaged produce.</a:t>
+            </a:r>
+            <a:endParaRPr lang="en-US" sz="1250" dirty="0"/>
+          </a:p>
+        </p:txBody>
+      </p:sp>
+      <p:sp>
+        <p:nvSpPr>
+          <p:cNvPr id="28" name="Text 26"/>
+          <p:cNvSpPr/>
+          <p:nvPr/>
+        </p:nvSpPr>
+        <p:spPr>
+          <a:xfrm>
+            <a:off x="777240" y="6455664"/>
+            <a:ext cx="7315200" cy="274320"/>
+          </a:xfrm>
+          <a:prstGeom prst="rect">
+            <a:avLst/>
+          </a:prstGeom>
+          <a:noFill/>
+          <a:ln/>
+        </p:spPr>
+        <p:txBody>
+          <a:bodyPr wrap="square" lIns="0" tIns="0" rIns="0" bIns="0" rtlCol="0" anchor="ctr"/>
+          <a:lstStyle/>
+          <a:p>
+            <a:pPr algn="l" indent="0" marL="0">
+              <a:buNone/>
+            </a:pPr>
+            <a:r>
+              <a:rPr lang="en-US" sz="900" dirty="0">
+                <a:solidFill>
+                  <a:srgbClr val="6B7A6E"/>
                 </a:solidFill>
                 <a:latin typeface="Calibri" pitchFamily="34" charset="0"/>
                 <a:ea typeface="Calibri" pitchFamily="34" charset="-122"/>
                 <a:cs typeface="Calibri" pitchFamily="34" charset="-120"/>
               </a:rPr>
-              <a:t>RECOMMENDATION
-</a:t>
-            </a:r>
-            <a:pPr indent="0" marL="0">
-              <a:lnSpc>
-                <a:spcPts val="1600"/>
-              </a:lnSpc>
-              <a:buNone/>
-            </a:pPr>
-            <a:r>
-              <a:rPr lang="en-US" sz="1250" dirty="0">
-                <a:solidFill>
-                  <a:srgbClr val="1C2E22"/>
-                </a:solidFill>
-                <a:latin typeface="Calibri" pitchFamily="34" charset="0"/>
-                <a:ea typeface="Calibri" pitchFamily="34" charset="-122"/>
-                <a:cs typeface="Calibri" pitchFamily="34" charset="-120"/>
-              </a:rPr>
-              <a:t>Group cluster members in the same app category, recommend across links, and bundle the strongest pairs.</a:t>
-            </a:r>
-            <a:endParaRPr lang="en-US" sz="1050" dirty="0"/>
-          </a:p>
-        </p:txBody>
-      </p:sp>
-      <p:sp>
-        <p:nvSpPr>
-          <p:cNvPr id="16" name="Text 13"/>
-          <p:cNvSpPr/>
-          <p:nvPr/>
-        </p:nvSpPr>
-        <p:spPr>
-          <a:xfrm>
-            <a:off x="777240" y="6455664"/>
-            <a:ext cx="7315200" cy="274320"/>
-          </a:xfrm>
-          <a:prstGeom prst="rect">
-            <a:avLst/>
-          </a:prstGeom>
-          <a:noFill/>
-          <a:ln/>
-        </p:spPr>
-        <p:txBody>
-          <a:bodyPr wrap="square" lIns="0" tIns="0" rIns="0" bIns="0" rtlCol="0" anchor="ctr"/>
-          <a:lstStyle/>
-          <a:p>
-            <a:pPr algn="l" indent="0" marL="0">
-              <a:buNone/>
-            </a:pPr>
-            <a:r>
-              <a:rPr lang="en-US" sz="900" dirty="0">
-                <a:solidFill>
-                  <a:srgbClr val="6B7A6E"/>
-                </a:solidFill>
-                <a:latin typeface="Calibri" pitchFamily="34" charset="0"/>
-                <a:ea typeface="Calibri" pitchFamily="34" charset="-122"/>
-                <a:cs typeface="Calibri" pitchFamily="34" charset="-120"/>
-              </a:rPr>
               <a:t>Grocery Product Placement Analysis  ·  Group 11</a:t>
             </a:r>
             <a:endParaRPr lang="en-US" sz="900" dirty="0"/>
@@ -10568,7 +10229,7 @@
       </p:sp>
       <p:sp>
         <p:nvSpPr>
-          <p:cNvPr id="17" name="Text 14"/>
+          <p:cNvPr id="29" name="Text 27"/>
           <p:cNvSpPr/>
           <p:nvPr/>
         </p:nvSpPr>
@@ -10747,30 +10408,16 @@
         </p:nvSpPr>
         <p:spPr>
           <a:xfrm>
-            <a:off x="8032090" y="1874520"/>
-            <a:ext cx="3382366" cy="2971800"/>
-          </a:xfrm>
-          <a:prstGeom prst="roundRect">
-            <a:avLst>
-              <a:gd name="adj" fmla="val 2462"/>
-            </a:avLst>
+            <a:off x="8123530" y="2217420"/>
+            <a:ext cx="64008" cy="3657600"/>
+          </a:xfrm>
+          <a:prstGeom prst="rect">
+            <a:avLst/>
           </a:prstGeom>
           <a:solidFill>
-            <a:srgbClr val="EEF2EC"/>
+            <a:srgbClr val="E07A3F"/>
           </a:solidFill>
-          <a:ln w="12700">
-            <a:solidFill>
-              <a:srgbClr val="D8E0D4"/>
-            </a:solidFill>
-            <a:prstDash val="solid"/>
-          </a:ln>
-          <a:effectLst>
-            <a:outerShdw sx="100000" sy="100000" kx="0" ky="0" algn="bl" rotWithShape="0" blurRad="114300" dist="38100" dir="8100000">
-              <a:srgbClr val="1C2E22">
-                <a:alpha val="16000"/>
-              </a:srgbClr>
-            </a:outerShdw>
-          </a:effectLst>
+          <a:ln/>
         </p:spPr>
       </p:sp>
       <p:sp>
@@ -10781,8 +10428,8 @@
         </p:nvSpPr>
         <p:spPr>
           <a:xfrm>
-            <a:off x="8324698" y="2121408"/>
-            <a:ext cx="2797150" cy="274320"/>
+            <a:off x="8416138" y="1988820"/>
+            <a:ext cx="2998318" cy="4114800"/>
           </a:xfrm>
           <a:prstGeom prst="rect">
             <a:avLst/>
@@ -10795,10 +10442,16 @@
           <a:lstStyle/>
           <a:p>
             <a:pPr indent="0" marL="0">
-              <a:buNone/>
-            </a:pPr>
-            <a:r>
-              <a:rPr lang="en-US" sz="1100" b="1" spc="200" kern="0" dirty="0">
+              <a:lnSpc>
+                <a:spcPts val="2600"/>
+              </a:lnSpc>
+              <a:spcAft>
+                <a:spcPts val="1000"/>
+              </a:spcAft>
+              <a:buNone/>
+            </a:pPr>
+            <a:r>
+              <a:rPr lang="en-US" sz="1150" b="1" spc="200" kern="0" dirty="0">
                 <a:solidFill>
                   <a:srgbClr val="2F6E4F"/>
                 </a:solidFill>
@@ -10806,44 +10459,20 @@
                 <a:ea typeface="Calibri" pitchFamily="34" charset="-122"/>
                 <a:cs typeface="Calibri" pitchFamily="34" charset="-120"/>
               </a:rPr>
-              <a:t>KEY FINDING</a:t>
-            </a:r>
-            <a:endParaRPr lang="en-US" sz="1100" dirty="0"/>
-          </a:p>
-        </p:txBody>
-      </p:sp>
-      <p:sp>
-        <p:nvSpPr>
-          <p:cNvPr id="7" name="Text 4"/>
-          <p:cNvSpPr/>
-          <p:nvPr/>
-        </p:nvSpPr>
-        <p:spPr>
-          <a:xfrm>
-            <a:off x="8324698" y="2432304"/>
-            <a:ext cx="2797150" cy="2286000"/>
-          </a:xfrm>
-          <a:prstGeom prst="rect">
-            <a:avLst/>
-          </a:prstGeom>
-          <a:noFill/>
-          <a:ln/>
-        </p:spPr>
-        <p:txBody>
-          <a:bodyPr wrap="square" lIns="0" tIns="0" rIns="0" bIns="0" rtlCol="0" anchor="t"/>
-          <a:lstStyle/>
-          <a:p>
+              <a:t>WHAT WE FOUND
+</a:t>
+            </a:r>
             <a:pPr indent="0" marL="0">
               <a:lnSpc>
-                <a:spcPts val="1800"/>
+                <a:spcPts val="2600"/>
               </a:lnSpc>
               <a:spcAft>
-                <a:spcPts val="800"/>
+                <a:spcPts val="1000"/>
               </a:spcAft>
               <a:buNone/>
             </a:pPr>
             <a:r>
-              <a:rPr lang="en-US" sz="1600" b="1" dirty="0">
+              <a:rPr lang="en-US" sz="2100" b="1" dirty="0">
                 <a:solidFill>
                   <a:srgbClr val="1C2E22"/>
                 </a:solidFill>
@@ -10851,145 +10480,45 @@
                 <a:ea typeface="Georgia" pitchFamily="34" charset="-122"/>
                 <a:cs typeface="Georgia" pitchFamily="34" charset="-120"/>
               </a:rPr>
-              <a:t>Loyalty runs on milk and water.</a:t>
-            </a:r>
-            <a:endParaRPr lang="en-US" sz="1600" dirty="0"/>
-          </a:p>
-          <a:p>
-            <a:pPr indent="0" marL="0">
-              <a:lnSpc>
-                <a:spcPts val="1800"/>
-              </a:lnSpc>
-              <a:buNone/>
-            </a:pPr>
-            <a:r>
-              <a:rPr lang="en-US" sz="1250" dirty="0">
-                <a:solidFill>
-                  <a:srgbClr val="1C2E22"/>
+              <a:t>Loyalty runs on milk and water — 84 to 86% reorder.</a:t>
+            </a:r>
+            <a:endParaRPr lang="en-US" sz="1150" dirty="0"/>
+          </a:p>
+        </p:txBody>
+      </p:sp>
+      <p:sp>
+        <p:nvSpPr>
+          <p:cNvPr id="8" name="Text 4"/>
+          <p:cNvSpPr/>
+          <p:nvPr/>
+        </p:nvSpPr>
+        <p:spPr>
+          <a:xfrm>
+            <a:off x="777240" y="6455664"/>
+            <a:ext cx="7315200" cy="274320"/>
+          </a:xfrm>
+          <a:prstGeom prst="rect">
+            <a:avLst/>
+          </a:prstGeom>
+          <a:noFill/>
+          <a:ln/>
+        </p:spPr>
+        <p:txBody>
+          <a:bodyPr wrap="square" lIns="0" tIns="0" rIns="0" bIns="0" rtlCol="0" anchor="ctr"/>
+          <a:lstStyle/>
+          <a:p>
+            <a:pPr algn="l" indent="0" marL="0">
+              <a:buNone/>
+            </a:pPr>
+            <a:r>
+              <a:rPr lang="en-US" sz="900" dirty="0">
+                <a:solidFill>
+                  <a:srgbClr val="6B7A6E"/>
                 </a:solidFill>
                 <a:latin typeface="Calibri" pitchFamily="34" charset="0"/>
                 <a:ea typeface="Calibri" pitchFamily="34" charset="-122"/>
                 <a:cs typeface="Calibri" pitchFamily="34" charset="-120"/>
               </a:rPr>
-              <a:t>The overall reorder rate is 58.9% — a highly habitual base. Among products with 500+ purchases, the highest reorder rates (84–86%) are almost entirely milk and water.</a:t>
-            </a:r>
-            <a:endParaRPr lang="en-US" sz="1600" dirty="0"/>
-          </a:p>
-        </p:txBody>
-      </p:sp>
-      <p:sp>
-        <p:nvSpPr>
-          <p:cNvPr id="8" name="Shape 5"/>
-          <p:cNvSpPr/>
-          <p:nvPr/>
-        </p:nvSpPr>
-        <p:spPr>
-          <a:xfrm>
-            <a:off x="8032090" y="5074920"/>
-            <a:ext cx="64008" cy="1097280"/>
-          </a:xfrm>
-          <a:prstGeom prst="rect">
-            <a:avLst/>
-          </a:prstGeom>
-          <a:solidFill>
-            <a:srgbClr val="E07A3F"/>
-          </a:solidFill>
-          <a:ln/>
-        </p:spPr>
-      </p:sp>
-      <p:sp>
-        <p:nvSpPr>
-          <p:cNvPr id="9" name="Text 6"/>
-          <p:cNvSpPr/>
-          <p:nvPr/>
-        </p:nvSpPr>
-        <p:spPr>
-          <a:xfrm>
-            <a:off x="8278978" y="5074920"/>
-            <a:ext cx="3135478" cy="1097280"/>
-          </a:xfrm>
-          <a:prstGeom prst="rect">
-            <a:avLst/>
-          </a:prstGeom>
-          <a:noFill/>
-          <a:ln/>
-        </p:spPr>
-        <p:txBody>
-          <a:bodyPr wrap="square" lIns="0" tIns="0" rIns="0" bIns="0" rtlCol="0" anchor="t"/>
-          <a:lstStyle/>
-          <a:p>
-            <a:pPr indent="0" marL="0">
-              <a:lnSpc>
-                <a:spcPts val="1600"/>
-              </a:lnSpc>
-              <a:buNone/>
-            </a:pPr>
-            <a:r>
-              <a:rPr lang="en-US" sz="1050" b="1" spc="150" kern="0" dirty="0">
-                <a:solidFill>
-                  <a:srgbClr val="E07A3F"/>
-                </a:solidFill>
-                <a:latin typeface="Calibri" pitchFamily="34" charset="0"/>
-                <a:ea typeface="Calibri" pitchFamily="34" charset="-122"/>
-                <a:cs typeface="Calibri" pitchFamily="34" charset="-120"/>
-              </a:rPr>
-              <a:t>RECOMMENDATION
-</a:t>
-            </a:r>
-            <a:pPr indent="0" marL="0">
-              <a:lnSpc>
-                <a:spcPts val="1600"/>
-              </a:lnSpc>
-              <a:buNone/>
-            </a:pPr>
-            <a:r>
-              <a:rPr lang="en-US" sz="1250" dirty="0">
-                <a:solidFill>
-                  <a:srgbClr val="1C2E22"/>
-                </a:solidFill>
-                <a:latin typeface="Calibri" pitchFamily="34" charset="0"/>
-                <a:ea typeface="Calibri" pitchFamily="34" charset="-122"/>
-                <a:cs typeface="Calibri" pitchFamily="34" charset="-120"/>
-              </a:rPr>
-              <a:t>Everyday staples are ideal candidates for subscriptions and automatic reorder reminders.</a:t>
-            </a:r>
-            <a:endParaRPr lang="en-US" sz="1050" dirty="0"/>
-          </a:p>
-        </p:txBody>
-      </p:sp>
-      <p:sp>
-        <p:nvSpPr>
-          <p:cNvPr id="10" name="Text 7"/>
-          <p:cNvSpPr/>
-          <p:nvPr/>
-        </p:nvSpPr>
-        <p:spPr>
-          <a:xfrm>
-            <a:off x="777240" y="6455664"/>
-            <a:ext cx="7315200" cy="274320"/>
-          </a:xfrm>
-          <a:prstGeom prst="rect">
-            <a:avLst/>
-          </a:prstGeom>
-          <a:noFill/>
-          <a:ln/>
-        </p:spPr>
-        <p:txBody>
-          <a:bodyPr wrap="square" lIns="0" tIns="0" rIns="0" bIns="0" rtlCol="0" anchor="ctr"/>
-          <a:lstStyle/>
-          <a:p>
-            <a:pPr algn="l" indent="0" marL="0">
-              <a:buNone/>
-            </a:pPr>
-            <a:r>
-              <a:rPr lang="en-US" sz="900" dirty="0">
-                <a:solidFill>
-                  <a:srgbClr val="6B7A6E"/>
-                </a:solidFill>
-                <a:latin typeface="Calibri" pitchFamily="34" charset="0"/>
-                <a:ea typeface="Calibri" pitchFamily="34" charset="-122"/>
-                <a:cs typeface="Calibri" pitchFamily="34" charset="-120"/>
-              </a:rPr>
               <a:t>Grocery Product Placement Analysis  ·  Group 11</a:t>
             </a:r>
             <a:endParaRPr lang="en-US" sz="900" dirty="0"/>
@@ -10998,7 +10527,7 @@
       </p:sp>
       <p:sp>
         <p:nvSpPr>
-          <p:cNvPr id="11" name="Text 8"/>
+          <p:cNvPr id="9" name="Text 5"/>
           <p:cNvSpPr/>
           <p:nvPr/>
         </p:nvSpPr>

</xml_diff>